<commit_message>
Chapitre 01 refondu : parcours academique sur la diapo 4, MG2 sur la diapo 6, nouvelle diapo 8 'Mon evolution chez MG2'
- Diapo 4 : identite + parcours academique (2018 / 2021 / 2023)
- Diapo 5 : diplomes detailles, devient une diapo de reserve
- Diapo 6 : arrivee chez MG2 + bandeau des missions actuelles
- Diapo 7 : competences (deplacees depuis la 8)
- Diapo 8 : NOUVELLE - innovation, accompagnement, formations, puis le constat
- Discours reecrit : 965 mots -> 7 min 58 s, chapitre 02 raccourci de moitie
</commit_message>
<xml_diff>
--- a/soutenance/KATATOOL_Soutenance_Youssef_OUBELLA.pptx
+++ b/soutenance/KATATOOL_Soutenance_Youssef_OUBELLA.pptx
@@ -2220,28 +2220,28 @@
             <a:pPr/>
             <a:r>
               <a:rPr lang="fr-FR" dirty="0"/>
-              <a:t>Je suis Chargé de Développement 2D, passionné d'électricité et de tout ce qui touche à la conception de faisceaux.</a:t>
+              <a:t>Bonjour à toutes et à tous. Je m'appelle Youssef OUBELLA, Chargé de Développement 2D au sein de l'équipe CD2D.</a:t>
             </a:r>
           </a:p>
           <a:p>
             <a:pPr/>
             <a:r>
               <a:rPr lang="fr-FR" dirty="0"/>
-              <a:t>Insister sur le double profil : ingénierie électrique ET création numérique / programmation. C'est ce double profil qui explique KATATOOL.</a:t>
+              <a:t>Mon parcours a commencé dans le domaine scientifique : Baccalauréat Sciences Mathématiques A en 2018 à Taroudant, puis Baccalauréat Sciences et Technologies en 2021 à Agadir.</a:t>
             </a:r>
           </a:p>
           <a:p>
             <a:pPr/>
             <a:r>
               <a:rPr lang="fr-FR" dirty="0"/>
-              <a:t>Qualités : patient, attentif au détail, capable d'expliquer un sujet technique à des publics variés.</a:t>
+              <a:t>Ensuite j'ai choisi le génie électrique : DUT à l'École Supérieure de Technologie de Guelmim, obtenu en 2023.</a:t>
             </a:r>
           </a:p>
           <a:p>
             <a:pPr/>
             <a:r>
               <a:rPr lang="fr-FR" dirty="0"/>
-              <a:t>NE PAS lire les contacts à voix haute.</a:t>
+              <a:t>Déroulez la colonne de droite de haut en bas. Si le temps presse, ne citez pas les noms de lycées en entier.</a:t>
             </a:r>
           </a:p>
         </p:txBody>
@@ -2294,21 +2294,21 @@
             <a:pPr/>
             <a:r>
               <a:rPr lang="fr-FR" dirty="0"/>
-              <a:t>FORMATION (45 s)</a:t>
+              <a:t>DIPLÔMES — DIAPO DE RÉSERVE (masquée dans la version 9 minutes)</a:t>
             </a:r>
           </a:p>
           <a:p>
             <a:pPr/>
             <a:r>
               <a:rPr lang="fr-FR" dirty="0"/>
-              <a:t>Parcours scientifique cohérent : maths, puis technologies, puis DUT Génie Électrique.</a:t>
+              <a:t>À garder sous la main : si un membre du jury demande un détail sur la formation, affichez-la pendant les questions.</a:t>
             </a:r>
           </a:p>
           <a:p>
             <a:pPr/>
             <a:r>
               <a:rPr lang="fr-FR" dirty="0"/>
-              <a:t>Ne pas détailler les matières — annoncer la progression et passer vite.</a:t>
+              <a:t>Le parcours académique est déjà résumé sur la diapo 4.</a:t>
             </a:r>
           </a:p>
         </p:txBody>
@@ -2368,21 +2368,21 @@
             <a:pPr/>
             <a:r>
               <a:rPr lang="fr-FR" dirty="0"/>
-              <a:t>Deux stages qui construisent les fondamentaux électriques : ONEE (protections des postes sources) puis Marsa Maroc (projet CPS, câblage d'armoires, schémas unifilaires AutoCAD, alimentation de la station RORO).</a:t>
+              <a:t>Deux stages d'abord : l'ONEE, sur les équipements de protection des postes sources. Puis Marsa Maroc, sur la mise à niveau des installations électriques du port d'Agadir — câblage des armoires électriques et réalisation des schémas unifilaires sur AutoCAD.</a:t>
             </a:r>
           </a:p>
           <a:p>
             <a:pPr/>
             <a:r>
               <a:rPr lang="fr-FR" dirty="0"/>
-              <a:t>Puis l'automobile : Concepteur Faisceaux 2D, et depuis septembre 2024 Chargé de Développement 2D.</a:t>
+              <a:t>En novembre 2023, j'ai rejoint MG2 comme Concepteur Faisceaux 2D. Depuis septembre 2024, je suis Chargé de Développement 2D.</a:t>
             </a:r>
           </a:p>
           <a:p>
             <a:pPr/>
             <a:r>
               <a:rPr lang="fr-FR" dirty="0"/>
-              <a:t>Message clé : une progression continue vers plus de responsabilité et plus de contact client.</a:t>
+              <a:t>Terminer sur le bandeau du bas : analyser, concevoir, valider et approuver les plans 2D avec Capital XC et PLM.</a:t>
             </a:r>
           </a:p>
         </p:txBody>
@@ -2435,28 +2435,21 @@
             <a:pPr/>
             <a:r>
               <a:rPr lang="fr-FR" dirty="0"/>
-              <a:t>MISSIONS (1 min)</a:t>
+              <a:t>COMPÉTENCES — DIAPO DE RÉSERVE (masquée dans la version 9 minutes)</a:t>
             </a:r>
           </a:p>
           <a:p>
             <a:pPr/>
             <a:r>
               <a:rPr lang="fr-FR" dirty="0"/>
-              <a:t>Trois familles de missions. Prendre un exemple concret pour chacune, sans réciter la liste.</a:t>
+              <a:t>À afficher pendant les questions si on vous interroge sur vos outils, ou sur votre capacité à avoir développé l'application vous-même.</a:t>
             </a:r>
           </a:p>
           <a:p>
             <a:pPr/>
             <a:r>
               <a:rPr lang="fr-FR" dirty="0"/>
-              <a:t>Exemple fort : valider et approuver officiellement les plans 2D sous Capital XC et PLM — c'est une responsabilité engageante.</a:t>
-            </a:r>
-          </a:p>
-          <a:p>
-            <a:pPr/>
-            <a:r>
-              <a:rPr lang="fr-FR" dirty="0"/>
-              <a:t>Terminer par : « Et c'est en faisant ce métier au quotidien que j'ai vu le problème dont je vais vous parler. »</a:t>
+              <a:t>La troisième colonne est la réponse à « comment avez-vous fait cela tout seul ? »</a:t>
             </a:r>
           </a:p>
         </p:txBody>
@@ -2509,21 +2502,42 @@
             <a:pPr/>
             <a:r>
               <a:rPr lang="fr-FR" dirty="0"/>
-              <a:t>COMPÉTENCES (45 s)</a:t>
+              <a:t>MON ÉVOLUTION CHEZ MG2 (1 min 15) — DIAPO CHARNIÈRE</a:t>
             </a:r>
           </a:p>
           <a:p>
             <a:pPr/>
             <a:r>
               <a:rPr lang="fr-FR" dirty="0"/>
-              <a:t>Trois blocs. Le troisième est celui qu'il faut souligner : c'est la compétence qui a permis de construire KATATOOL en interne, sans budget et sans prestataire externe.</a:t>
+              <a:t>Depuis mon arrivée chez MG2, j'ai toujours eu envie de faire quelque chose de nouveau et d'apporter une valeur supplémentaire à l'équipe. J'ai donc commencé à proposer des sujets d'innovation.</a:t>
             </a:r>
           </a:p>
           <a:p>
             <a:pPr/>
             <a:r>
               <a:rPr lang="fr-FR" dirty="0"/>
-              <a:t>Trois langues de travail : arabe, français, anglais.</a:t>
+              <a:t>J'ai aussi eu l'occasion d'accompagner des stagiaires et des nouveaux arrivants, et d'animer des formations pour l'équipe 2D, surtout sur Capital XC.</a:t>
+            </a:r>
+          </a:p>
+          <a:p>
+            <a:pPr/>
+            <a:r>
+              <a:rPr lang="fr-FR" dirty="0"/>
+              <a:t>Avec le temps, j'ai remarqué un besoin : un nouvel arrivant doit apprendre beaucoup de choses en peu de temps — les bases du métier, Capital XC, les méthodes de travail et l'environnement du projet.</a:t>
+            </a:r>
+          </a:p>
+          <a:p>
+            <a:pPr/>
+            <a:r>
+              <a:rPr lang="fr-FR" dirty="0"/>
+              <a:t>MARQUEZ UN TEMPS, puis : « C'est à partir de ce constat que j'ai pensé à KATATOOL. »</a:t>
+            </a:r>
+          </a:p>
+          <a:p>
+            <a:pPr/>
+            <a:r>
+              <a:rPr lang="fr-FR" dirty="0"/>
+              <a:t>C'est la diapositive qui relie votre parcours au projet. Ne la survolez pas : c'est elle qui rend la suite légitime.</a:t>
             </a:r>
           </a:p>
         </p:txBody>
@@ -22441,7 +22455,7 @@
                 <a:latin typeface="Segoe UI"/>
                 <a:cs typeface="Segoe UI"/>
               </a:rPr>
-              <a:t>Qui suis-je</a:t>
+              <a:t>Qui suis-je ?</a:t>
             </a:r>
           </a:p>
         </p:txBody>
@@ -22454,8 +22468,8 @@
         </p:nvSpPr>
         <p:spPr>
           <a:xfrm>
-            <a:off x="777240" y="2103120"/>
-            <a:ext cx="2788920" cy="3429000"/>
+            <a:off x="777240" y="2084832"/>
+            <a:ext cx="2788920" cy="3931920"/>
           </a:xfrm>
           <a:prstGeom prst="roundRect">
             <a:avLst>
@@ -22507,7 +22521,7 @@
         <p:spPr>
           <a:xfrm>
             <a:off x="4069080" y="2121408"/>
-            <a:ext cx="7345375" cy="548640"/>
+            <a:ext cx="7345375" cy="566928"/>
           </a:xfrm>
           <a:prstGeom prst="rect">
             <a:avLst/>
@@ -22547,7 +22561,7 @@
         </p:nvSpPr>
         <p:spPr>
           <a:xfrm>
-            <a:off x="4069080" y="2688336"/>
+            <a:off x="4069080" y="2706624"/>
             <a:ext cx="7345375" cy="310896"/>
           </a:xfrm>
           <a:prstGeom prst="rect">
@@ -22575,7 +22589,7 @@
                 <a:latin typeface="Segoe UI"/>
                 <a:cs typeface="Segoe UI"/>
               </a:rPr>
-              <a:t>Chargé de Développement 2D · Équipe CD2D</a:t>
+              <a:t>Chargé de Développement 2D  ·  Équipe CD2D  ·  MG2 Engineering</a:t>
             </a:r>
           </a:p>
         </p:txBody>
@@ -22588,8 +22602,8 @@
         </p:nvSpPr>
         <p:spPr>
           <a:xfrm>
-            <a:off x="4069080" y="3200400"/>
-            <a:ext cx="7162495" cy="1417320"/>
+            <a:off x="4069080" y="3145536"/>
+            <a:ext cx="7162495" cy="960120"/>
           </a:xfrm>
           <a:prstGeom prst="rect">
             <a:avLst/>
@@ -22619,238 +22633,485 @@
                 <a:latin typeface="Segoe UI"/>
                 <a:cs typeface="Segoe UI"/>
               </a:rPr>
-              <a:t>Responsable du développement 2D dans le domaine de l'automobile. Solide maîtrise de l'analyse des circuits, des systèmes énergétiques et de l'électronique.</a:t>
-            </a:r>
-          </a:p>
+              <a:t>Passionné par l'électricité et par la conception de faisceaux : analyse des circuits, systèmes énergétiques, électronique. Un parcours entièrement scientifique et technique.</a:t>
+            </a:r>
+          </a:p>
+        </p:txBody>
+      </p:sp>
+      <p:sp>
+        <p:nvSpPr>
+          <p:cNvPr id="11" name="Text"/>
+          <p:cNvSpPr/>
+          <p:nvPr/>
+        </p:nvSpPr>
+        <p:spPr>
+          <a:xfrm>
+            <a:off x="4069080" y="4224528"/>
+            <a:ext cx="7345375" cy="274320"/>
+          </a:xfrm>
+          <a:prstGeom prst="rect">
+            <a:avLst/>
+          </a:prstGeom>
+          <a:noFill/>
+          <a:ln>
+            <a:noFill/>
+          </a:ln>
+        </p:spPr>
+        <p:txBody>
+          <a:bodyPr wrap="square" lIns="0" tIns="0" rIns="0" bIns="0" anchor="t">
+            <a:noAutofit/>
+          </a:bodyPr>
+          <a:lstStyle/>
           <a:p>
             <a:pPr marL="0" indent="0" algn="l">
-              <a:lnSpc>
-                <a:spcPct val="142000"/>
-              </a:lnSpc>
-              <a:spcBef>
-                <a:spcPts val="800"/>
-              </a:spcBef>
-              <a:buNone/>
-            </a:pPr>
-            <a:r>
-              <a:rPr lang="fr-FR" sz="1350" dirty="0">
-                <a:solidFill>
-                  <a:srgbClr val="9FB6CE"/>
-                </a:solidFill>
-                <a:latin typeface="Segoe UI"/>
-                <a:cs typeface="Segoe UI"/>
-              </a:rPr>
-              <a:t>Un second profil, numérique : programmation, création graphique et motion design — c'est de là qu'est né KATATOOL.</a:t>
-            </a:r>
-          </a:p>
-        </p:txBody>
-      </p:sp>
-      <p:sp>
-        <p:nvSpPr>
-          <p:cNvPr id="11" name="Bloc"/>
-          <p:cNvSpPr/>
-          <p:nvPr/>
-        </p:nvSpPr>
-        <p:spPr>
-          <a:xfrm>
-            <a:off x="4069080" y="4864608"/>
-            <a:ext cx="2314346" cy="749808"/>
-          </a:xfrm>
-          <a:prstGeom prst="roundRect">
-            <a:avLst>
-              <a:gd name="adj" fmla="val 9000"/>
-            </a:avLst>
+              <a:buNone/>
+            </a:pPr>
+            <a:r>
+              <a:rPr lang="fr-FR" sz="1000" dirty="0" b="1" spc="180" cap="all">
+                <a:solidFill>
+                  <a:srgbClr val="6E89A6"/>
+                </a:solidFill>
+                <a:latin typeface="Segoe UI"/>
+                <a:cs typeface="Segoe UI"/>
+              </a:rPr>
+              <a:t>Parcours académique</a:t>
+            </a:r>
+          </a:p>
+        </p:txBody>
+      </p:sp>
+      <p:sp>
+        <p:nvSpPr>
+          <p:cNvPr id="12" name="Axe"/>
+          <p:cNvSpPr/>
+          <p:nvPr/>
+        </p:nvSpPr>
+        <p:spPr>
+          <a:xfrm>
+            <a:off x="4892040" y="4700016"/>
+            <a:ext cx="20117" cy="1133856"/>
+          </a:xfrm>
+          <a:prstGeom prst="rect">
+            <a:avLst/>
           </a:prstGeom>
           <a:solidFill>
-            <a:srgbClr val="0F2842">
-              <a:alpha val="48000"/>
-            </a:srgbClr>
+            <a:srgbClr val="2A4A6B"/>
           </a:solidFill>
-          <a:ln w="15240" cap="flat" cmpd="sng" algn="ctr">
+          <a:ln>
+            <a:noFill/>
+          </a:ln>
+        </p:spPr>
+        <p:txBody>
+          <a:bodyPr wrap="square" lIns="0" tIns="0" rIns="0" bIns="0" anchor="t">
+            <a:noAutofit/>
+          </a:bodyPr>
+          <a:lstStyle/>
+          <a:p>
+            <a:pPr/>
+            <a:endParaRPr lang="fr-FR"/>
+          </a:p>
+        </p:txBody>
+      </p:sp>
+      <p:sp>
+        <p:nvSpPr>
+          <p:cNvPr id="13" name="Text"/>
+          <p:cNvSpPr/>
+          <p:nvPr/>
+        </p:nvSpPr>
+        <p:spPr>
+          <a:xfrm>
+            <a:off x="4069080" y="4535424"/>
+            <a:ext cx="713232" cy="457200"/>
+          </a:xfrm>
+          <a:prstGeom prst="rect">
+            <a:avLst/>
+          </a:prstGeom>
+          <a:noFill/>
+          <a:ln>
+            <a:noFill/>
+          </a:ln>
+        </p:spPr>
+        <p:txBody>
+          <a:bodyPr wrap="square" lIns="0" tIns="0" rIns="0" bIns="0" anchor="ctr">
+            <a:noAutofit/>
+          </a:bodyPr>
+          <a:lstStyle/>
+          <a:p>
+            <a:pPr marL="0" indent="0" algn="r">
+              <a:buNone/>
+            </a:pPr>
+            <a:r>
+              <a:rPr lang="fr-FR" sz="1250" dirty="0" b="1">
+                <a:solidFill>
+                  <a:srgbClr val="5B9DF9"/>
+                </a:solidFill>
+                <a:latin typeface="Segoe UI"/>
+                <a:cs typeface="Segoe UI"/>
+              </a:rPr>
+              <a:t>2018</a:t>
+            </a:r>
+          </a:p>
+        </p:txBody>
+      </p:sp>
+      <p:sp>
+        <p:nvSpPr>
+          <p:cNvPr id="14" name="Point"/>
+          <p:cNvSpPr/>
+          <p:nvPr/>
+        </p:nvSpPr>
+        <p:spPr>
+          <a:xfrm>
+            <a:off x="4841748" y="4709160"/>
+            <a:ext cx="118872" cy="118872"/>
+          </a:xfrm>
+          <a:prstGeom prst="ellipse">
+            <a:avLst/>
+          </a:prstGeom>
+          <a:solidFill>
+            <a:srgbClr val="5B9DF9"/>
+          </a:solidFill>
+          <a:ln w="20320" cap="flat" cmpd="sng" algn="ctr">
             <a:solidFill>
-              <a:srgbClr val="5B9DF9">
-                <a:alpha val="55000"/>
-              </a:srgbClr>
+              <a:srgbClr val="040E18"/>
             </a:solidFill>
             <a:prstDash val="solid"/>
           </a:ln>
         </p:spPr>
         <p:txBody>
+          <a:bodyPr wrap="square" lIns="0" tIns="0" rIns="0" bIns="0" anchor="t">
+            <a:noAutofit/>
+          </a:bodyPr>
+          <a:lstStyle/>
+          <a:p>
+            <a:pPr/>
+            <a:endParaRPr lang="fr-FR"/>
+          </a:p>
+        </p:txBody>
+      </p:sp>
+      <p:sp>
+        <p:nvSpPr>
+          <p:cNvPr id="15" name="Text"/>
+          <p:cNvSpPr/>
+          <p:nvPr/>
+        </p:nvSpPr>
+        <p:spPr>
+          <a:xfrm>
+            <a:off x="5120640" y="4535424"/>
+            <a:ext cx="6293815" cy="457200"/>
+          </a:xfrm>
+          <a:prstGeom prst="rect">
+            <a:avLst/>
+          </a:prstGeom>
+          <a:noFill/>
+          <a:ln>
+            <a:noFill/>
+          </a:ln>
+        </p:spPr>
+        <p:txBody>
           <a:bodyPr wrap="square" lIns="0" tIns="0" rIns="0" bIns="0" anchor="ctr">
             <a:noAutofit/>
           </a:bodyPr>
           <a:lstStyle/>
           <a:p>
-            <a:pPr marL="0" indent="0" algn="ctr">
-              <a:buNone/>
-            </a:pPr>
-            <a:r>
-              <a:rPr lang="fr-FR" sz="900" dirty="0" b="1" spc="140">
-                <a:solidFill>
-                  <a:srgbClr val="6E89A6"/>
-                </a:solidFill>
-                <a:latin typeface="Segoe UI"/>
-                <a:cs typeface="Segoe UI"/>
-              </a:rPr>
-              <a:t>MÉTIER</a:t>
-            </a:r>
-          </a:p>
-          <a:p>
-            <a:pPr marL="0" indent="0" algn="ctr">
+            <a:pPr marL="0" indent="0" algn="l">
+              <a:buNone/>
+            </a:pPr>
+            <a:r>
+              <a:rPr lang="fr-FR" sz="1250" dirty="0" b="1">
+                <a:solidFill>
+                  <a:srgbClr val="FFFFFF"/>
+                </a:solidFill>
+                <a:latin typeface="Segoe UI"/>
+                <a:cs typeface="Segoe UI"/>
+              </a:rPr>
+              <a:t>Baccalauréat Sciences Mathématiques A</a:t>
+            </a:r>
+          </a:p>
+          <a:p>
+            <a:pPr marL="0" indent="0" algn="l">
               <a:spcBef>
-                <a:spcPts val="300"/>
+                <a:spcPts val="200"/>
               </a:spcBef>
               <a:buNone/>
             </a:pPr>
             <a:r>
-              <a:rPr lang="fr-FR" sz="1300" dirty="0" b="1">
-                <a:solidFill>
-                  <a:srgbClr val="5B9DF9"/>
-                </a:solidFill>
-                <a:latin typeface="Segoe UI"/>
-                <a:cs typeface="Segoe UI"/>
-              </a:rPr>
-              <a:t>Faisceaux 2D</a:t>
-            </a:r>
-          </a:p>
-        </p:txBody>
-      </p:sp>
-      <p:sp>
-        <p:nvSpPr>
-          <p:cNvPr id="12" name="Bloc"/>
-          <p:cNvSpPr/>
-          <p:nvPr/>
-        </p:nvSpPr>
-        <p:spPr>
-          <a:xfrm>
-            <a:off x="6584594" y="4864608"/>
-            <a:ext cx="2314346" cy="749808"/>
-          </a:xfrm>
-          <a:prstGeom prst="roundRect">
-            <a:avLst>
-              <a:gd name="adj" fmla="val 9000"/>
-            </a:avLst>
+              <a:rPr lang="fr-FR" sz="1050" dirty="0">
+                <a:solidFill>
+                  <a:srgbClr val="9FB6CE"/>
+                </a:solidFill>
+                <a:latin typeface="Segoe UI"/>
+                <a:cs typeface="Segoe UI"/>
+              </a:rPr>
+              <a:t>Lycée Ibn Soulaiman Roudani — Taroudant</a:t>
+            </a:r>
+          </a:p>
+        </p:txBody>
+      </p:sp>
+      <p:sp>
+        <p:nvSpPr>
+          <p:cNvPr id="16" name="Text"/>
+          <p:cNvSpPr/>
+          <p:nvPr/>
+        </p:nvSpPr>
+        <p:spPr>
+          <a:xfrm>
+            <a:off x="4069080" y="5038344"/>
+            <a:ext cx="713232" cy="457200"/>
+          </a:xfrm>
+          <a:prstGeom prst="rect">
+            <a:avLst/>
+          </a:prstGeom>
+          <a:noFill/>
+          <a:ln>
+            <a:noFill/>
+          </a:ln>
+        </p:spPr>
+        <p:txBody>
+          <a:bodyPr wrap="square" lIns="0" tIns="0" rIns="0" bIns="0" anchor="ctr">
+            <a:noAutofit/>
+          </a:bodyPr>
+          <a:lstStyle/>
+          <a:p>
+            <a:pPr marL="0" indent="0" algn="r">
+              <a:buNone/>
+            </a:pPr>
+            <a:r>
+              <a:rPr lang="fr-FR" sz="1250" dirty="0" b="1">
+                <a:solidFill>
+                  <a:srgbClr val="22D3EE"/>
+                </a:solidFill>
+                <a:latin typeface="Segoe UI"/>
+                <a:cs typeface="Segoe UI"/>
+              </a:rPr>
+              <a:t>2021</a:t>
+            </a:r>
+          </a:p>
+        </p:txBody>
+      </p:sp>
+      <p:sp>
+        <p:nvSpPr>
+          <p:cNvPr id="17" name="Point"/>
+          <p:cNvSpPr/>
+          <p:nvPr/>
+        </p:nvSpPr>
+        <p:spPr>
+          <a:xfrm>
+            <a:off x="4841748" y="5212080"/>
+            <a:ext cx="118872" cy="118872"/>
+          </a:xfrm>
+          <a:prstGeom prst="ellipse">
+            <a:avLst/>
           </a:prstGeom>
           <a:solidFill>
-            <a:srgbClr val="0F2842">
-              <a:alpha val="48000"/>
-            </a:srgbClr>
+            <a:srgbClr val="22D3EE"/>
           </a:solidFill>
-          <a:ln w="15240" cap="flat" cmpd="sng" algn="ctr">
+          <a:ln w="20320" cap="flat" cmpd="sng" algn="ctr">
             <a:solidFill>
-              <a:srgbClr val="34D399">
-                <a:alpha val="55000"/>
-              </a:srgbClr>
+              <a:srgbClr val="040E18"/>
             </a:solidFill>
             <a:prstDash val="solid"/>
           </a:ln>
         </p:spPr>
         <p:txBody>
+          <a:bodyPr wrap="square" lIns="0" tIns="0" rIns="0" bIns="0" anchor="t">
+            <a:noAutofit/>
+          </a:bodyPr>
+          <a:lstStyle/>
+          <a:p>
+            <a:pPr/>
+            <a:endParaRPr lang="fr-FR"/>
+          </a:p>
+        </p:txBody>
+      </p:sp>
+      <p:sp>
+        <p:nvSpPr>
+          <p:cNvPr id="18" name="Text"/>
+          <p:cNvSpPr/>
+          <p:nvPr/>
+        </p:nvSpPr>
+        <p:spPr>
+          <a:xfrm>
+            <a:off x="5120640" y="5038344"/>
+            <a:ext cx="6293815" cy="457200"/>
+          </a:xfrm>
+          <a:prstGeom prst="rect">
+            <a:avLst/>
+          </a:prstGeom>
+          <a:noFill/>
+          <a:ln>
+            <a:noFill/>
+          </a:ln>
+        </p:spPr>
+        <p:txBody>
           <a:bodyPr wrap="square" lIns="0" tIns="0" rIns="0" bIns="0" anchor="ctr">
             <a:noAutofit/>
           </a:bodyPr>
           <a:lstStyle/>
           <a:p>
-            <a:pPr marL="0" indent="0" algn="ctr">
-              <a:buNone/>
-            </a:pPr>
-            <a:r>
-              <a:rPr lang="fr-FR" sz="900" dirty="0" b="1" spc="140">
-                <a:solidFill>
-                  <a:srgbClr val="6E89A6"/>
-                </a:solidFill>
-                <a:latin typeface="Segoe UI"/>
-                <a:cs typeface="Segoe UI"/>
-              </a:rPr>
-              <a:t>SYSTÈMES</a:t>
-            </a:r>
-          </a:p>
-          <a:p>
-            <a:pPr marL="0" indent="0" algn="ctr">
+            <a:pPr marL="0" indent="0" algn="l">
+              <a:buNone/>
+            </a:pPr>
+            <a:r>
+              <a:rPr lang="fr-FR" sz="1250" dirty="0" b="1">
+                <a:solidFill>
+                  <a:srgbClr val="FFFFFF"/>
+                </a:solidFill>
+                <a:latin typeface="Segoe UI"/>
+                <a:cs typeface="Segoe UI"/>
+              </a:rPr>
+              <a:t>Baccalauréat Sciences et Technologies</a:t>
+            </a:r>
+          </a:p>
+          <a:p>
+            <a:pPr marL="0" indent="0" algn="l">
               <a:spcBef>
-                <a:spcPts val="300"/>
+                <a:spcPts val="200"/>
               </a:spcBef>
               <a:buNone/>
             </a:pPr>
             <a:r>
-              <a:rPr lang="fr-FR" sz="1300" dirty="0" b="1">
+              <a:rPr lang="fr-FR" sz="1050" dirty="0">
+                <a:solidFill>
+                  <a:srgbClr val="9FB6CE"/>
+                </a:solidFill>
+                <a:latin typeface="Segoe UI"/>
+                <a:cs typeface="Segoe UI"/>
+              </a:rPr>
+              <a:t>Lycée Al Inbiaat — Agadir</a:t>
+            </a:r>
+          </a:p>
+        </p:txBody>
+      </p:sp>
+      <p:sp>
+        <p:nvSpPr>
+          <p:cNvPr id="19" name="Text"/>
+          <p:cNvSpPr/>
+          <p:nvPr/>
+        </p:nvSpPr>
+        <p:spPr>
+          <a:xfrm>
+            <a:off x="4069080" y="5541264"/>
+            <a:ext cx="713232" cy="457200"/>
+          </a:xfrm>
+          <a:prstGeom prst="rect">
+            <a:avLst/>
+          </a:prstGeom>
+          <a:noFill/>
+          <a:ln>
+            <a:noFill/>
+          </a:ln>
+        </p:spPr>
+        <p:txBody>
+          <a:bodyPr wrap="square" lIns="0" tIns="0" rIns="0" bIns="0" anchor="ctr">
+            <a:noAutofit/>
+          </a:bodyPr>
+          <a:lstStyle/>
+          <a:p>
+            <a:pPr marL="0" indent="0" algn="r">
+              <a:buNone/>
+            </a:pPr>
+            <a:r>
+              <a:rPr lang="fr-FR" sz="1250" dirty="0" b="1">
                 <a:solidFill>
                   <a:srgbClr val="34D399"/>
                 </a:solidFill>
                 <a:latin typeface="Segoe UI"/>
                 <a:cs typeface="Segoe UI"/>
               </a:rPr>
-              <a:t>Capital XC · PLM</a:t>
-            </a:r>
-          </a:p>
-        </p:txBody>
-      </p:sp>
-      <p:sp>
-        <p:nvSpPr>
-          <p:cNvPr id="13" name="Bloc"/>
-          <p:cNvSpPr/>
-          <p:nvPr/>
-        </p:nvSpPr>
-        <p:spPr>
-          <a:xfrm>
-            <a:off x="9100109" y="4864608"/>
-            <a:ext cx="2314346" cy="749808"/>
-          </a:xfrm>
-          <a:prstGeom prst="roundRect">
-            <a:avLst>
-              <a:gd name="adj" fmla="val 9000"/>
-            </a:avLst>
+              <a:t>2023</a:t>
+            </a:r>
+          </a:p>
+        </p:txBody>
+      </p:sp>
+      <p:sp>
+        <p:nvSpPr>
+          <p:cNvPr id="20" name="Point"/>
+          <p:cNvSpPr/>
+          <p:nvPr/>
+        </p:nvSpPr>
+        <p:spPr>
+          <a:xfrm>
+            <a:off x="4841748" y="5715000"/>
+            <a:ext cx="118872" cy="118872"/>
+          </a:xfrm>
+          <a:prstGeom prst="ellipse">
+            <a:avLst/>
           </a:prstGeom>
           <a:solidFill>
-            <a:srgbClr val="0F2842">
-              <a:alpha val="48000"/>
-            </a:srgbClr>
+            <a:srgbClr val="34D399"/>
           </a:solidFill>
-          <a:ln w="15240" cap="flat" cmpd="sng" algn="ctr">
+          <a:ln w="20320" cap="flat" cmpd="sng" algn="ctr">
             <a:solidFill>
-              <a:srgbClr val="A78BFA">
-                <a:alpha val="55000"/>
-              </a:srgbClr>
+              <a:srgbClr val="040E18"/>
             </a:solidFill>
             <a:prstDash val="solid"/>
           </a:ln>
         </p:spPr>
         <p:txBody>
+          <a:bodyPr wrap="square" lIns="0" tIns="0" rIns="0" bIns="0" anchor="t">
+            <a:noAutofit/>
+          </a:bodyPr>
+          <a:lstStyle/>
+          <a:p>
+            <a:pPr/>
+            <a:endParaRPr lang="fr-FR"/>
+          </a:p>
+        </p:txBody>
+      </p:sp>
+      <p:sp>
+        <p:nvSpPr>
+          <p:cNvPr id="21" name="Text"/>
+          <p:cNvSpPr/>
+          <p:nvPr/>
+        </p:nvSpPr>
+        <p:spPr>
+          <a:xfrm>
+            <a:off x="5120640" y="5541264"/>
+            <a:ext cx="6293815" cy="457200"/>
+          </a:xfrm>
+          <a:prstGeom prst="rect">
+            <a:avLst/>
+          </a:prstGeom>
+          <a:noFill/>
+          <a:ln>
+            <a:noFill/>
+          </a:ln>
+        </p:spPr>
+        <p:txBody>
           <a:bodyPr wrap="square" lIns="0" tIns="0" rIns="0" bIns="0" anchor="ctr">
             <a:noAutofit/>
           </a:bodyPr>
           <a:lstStyle/>
           <a:p>
-            <a:pPr marL="0" indent="0" algn="ctr">
-              <a:buNone/>
-            </a:pPr>
-            <a:r>
-              <a:rPr lang="fr-FR" sz="900" dirty="0" b="1" spc="140">
-                <a:solidFill>
-                  <a:srgbClr val="6E89A6"/>
-                </a:solidFill>
-                <a:latin typeface="Segoe UI"/>
-                <a:cs typeface="Segoe UI"/>
-              </a:rPr>
-              <a:t>SECOND PROFIL</a:t>
-            </a:r>
-          </a:p>
-          <a:p>
-            <a:pPr marL="0" indent="0" algn="ctr">
+            <a:pPr marL="0" indent="0" algn="l">
+              <a:buNone/>
+            </a:pPr>
+            <a:r>
+              <a:rPr lang="fr-FR" sz="1250" dirty="0" b="1">
+                <a:solidFill>
+                  <a:srgbClr val="FFFFFF"/>
+                </a:solidFill>
+                <a:latin typeface="Segoe UI"/>
+                <a:cs typeface="Segoe UI"/>
+              </a:rPr>
+              <a:t>DUT Génie Électrique</a:t>
+            </a:r>
+          </a:p>
+          <a:p>
+            <a:pPr marL="0" indent="0" algn="l">
               <a:spcBef>
-                <a:spcPts val="300"/>
+                <a:spcPts val="200"/>
               </a:spcBef>
               <a:buNone/>
             </a:pPr>
             <a:r>
-              <a:rPr lang="fr-FR" sz="1300" dirty="0" b="1">
-                <a:solidFill>
-                  <a:srgbClr val="A78BFA"/>
-                </a:solidFill>
-                <a:latin typeface="Segoe UI"/>
-                <a:cs typeface="Segoe UI"/>
-              </a:rPr>
-              <a:t>Développement</a:t>
+              <a:rPr lang="fr-FR" sz="1050" dirty="0">
+                <a:solidFill>
+                  <a:srgbClr val="9FB6CE"/>
+                </a:solidFill>
+                <a:latin typeface="Segoe UI"/>
+                <a:cs typeface="Segoe UI"/>
+              </a:rPr>
+              <a:t>École Supérieure de Technologie de Guelmim — Université Ibn Zohr</a:t>
             </a:r>
           </a:p>
         </p:txBody>
@@ -23410,7 +23671,7 @@
                 <a:latin typeface="Segoe UI"/>
                 <a:cs typeface="Segoe UI"/>
               </a:rPr>
-              <a:t>Baccalauréat Sciences de Technologies</a:t>
+              <a:t>Baccalauréat Sciences et Technologies</a:t>
             </a:r>
           </a:p>
           <a:p>
@@ -23828,7 +24089,7 @@
                 <a:latin typeface="Segoe UI"/>
                 <a:cs typeface="Segoe UI"/>
               </a:rPr>
-              <a:t>Une progression continue</a:t>
+              <a:t>Mon parcours professionnel</a:t>
             </a:r>
           </a:p>
         </p:txBody>
@@ -24012,7 +24273,7 @@
                 <a:latin typeface="Segoe UI"/>
                 <a:cs typeface="Segoe UI"/>
               </a:rPr>
-              <a:t>Stage d'initiation — recensement des équipements de protection des postes sources.</a:t>
+              <a:t>Stage — équipements de protection des postes sources.</a:t>
             </a:r>
           </a:p>
         </p:txBody>
@@ -24164,7 +24425,7 @@
                 <a:latin typeface="Segoe UI"/>
                 <a:cs typeface="Segoe UI"/>
               </a:rPr>
-              <a:t>Projet CPS : mise à niveau des installations électriques du port d'Agadir. Schémas unifilaires AutoCAD.</a:t>
+              <a:t>Stage — installations électriques du port d'Agadir. Câblage d'armoires, schémas unifilaires AutoCAD.</a:t>
             </a:r>
           </a:p>
         </p:txBody>
@@ -24316,7 +24577,7 @@
                 <a:latin typeface="Segoe UI"/>
                 <a:cs typeface="Segoe UI"/>
               </a:rPr>
-              <a:t>Validation des dessins 2D sous Capital XC, plans d'assemblage véhicule et gabarits, FETE.</a:t>
+              <a:t>Arrivée chez MG2 Engineering. Conception et validation des faisceaux 2D.</a:t>
             </a:r>
           </a:p>
         </p:txBody>
@@ -24468,7 +24729,77 @@
                 <a:latin typeface="Segoe UI"/>
                 <a:cs typeface="Segoe UI"/>
               </a:rPr>
-              <a:t>Validation et approbation des plans 2D, SDP, PTA, études de faisabilité. Poste actuel.</a:t>
+              <a:t>Poste actuel, au sein de l'équipe CD2D.</a:t>
+            </a:r>
+          </a:p>
+        </p:txBody>
+      </p:sp>
+      <p:sp>
+        <p:nvSpPr>
+          <p:cNvPr id="20" name="Bandeau"/>
+          <p:cNvSpPr/>
+          <p:nvPr/>
+        </p:nvSpPr>
+        <p:spPr>
+          <a:xfrm>
+            <a:off x="777240" y="5431536"/>
+            <a:ext cx="10637215" cy="694944"/>
+          </a:xfrm>
+          <a:prstGeom prst="roundRect">
+            <a:avLst>
+              <a:gd name="adj" fmla="val 9000"/>
+            </a:avLst>
+          </a:prstGeom>
+          <a:solidFill>
+            <a:srgbClr val="5B9DF9">
+              <a:alpha val="10000"/>
+            </a:srgbClr>
+          </a:solidFill>
+          <a:ln w="16510" cap="flat" cmpd="sng" algn="ctr">
+            <a:solidFill>
+              <a:srgbClr val="5B9DF9">
+                <a:alpha val="50000"/>
+              </a:srgbClr>
+            </a:solidFill>
+            <a:prstDash val="solid"/>
+          </a:ln>
+        </p:spPr>
+        <p:txBody>
+          <a:bodyPr wrap="square" lIns="274320" tIns="91440" rIns="274320" bIns="91440" anchor="ctr">
+            <a:noAutofit/>
+          </a:bodyPr>
+          <a:lstStyle/>
+          <a:p>
+            <a:pPr marL="0" indent="0" algn="ctr">
+              <a:buNone/>
+            </a:pPr>
+            <a:r>
+              <a:rPr lang="fr-FR" sz="950" dirty="0" b="1" spc="180" cap="all">
+                <a:solidFill>
+                  <a:srgbClr val="6E89A6"/>
+                </a:solidFill>
+                <a:latin typeface="Segoe UI"/>
+                <a:cs typeface="Segoe UI"/>
+              </a:rPr>
+              <a:t>Aujourd'hui</a:t>
+            </a:r>
+          </a:p>
+          <a:p>
+            <a:pPr marL="0" indent="0" algn="ctr">
+              <a:spcBef>
+                <a:spcPts val="300"/>
+              </a:spcBef>
+              <a:buNone/>
+            </a:pPr>
+            <a:r>
+              <a:rPr lang="fr-FR" sz="1450" dirty="0" b="1">
+                <a:solidFill>
+                  <a:srgbClr val="FFFFFF"/>
+                </a:solidFill>
+                <a:latin typeface="Segoe UI"/>
+                <a:cs typeface="Segoe UI"/>
+              </a:rPr>
+              <a:t>Analyser, concevoir, valider et approuver les plans 2D avec Capital XC et PLM.</a:t>
             </a:r>
           </a:p>
         </p:txBody>
@@ -24669,7 +25000,7 @@
                 <a:latin typeface="Segoe UI"/>
                 <a:cs typeface="Segoe UI"/>
               </a:rPr>
-              <a:t>Mon poste aujourd'hui</a:t>
+              <a:t>Compétences</a:t>
             </a:r>
           </a:p>
         </p:txBody>
@@ -24713,7 +25044,7 @@
                 <a:latin typeface="Segoe UI"/>
                 <a:cs typeface="Segoe UI"/>
               </a:rPr>
-              <a:t>Mes missions au quotidien</a:t>
+              <a:t>Métier, technique et numérique</a:t>
             </a:r>
           </a:p>
         </p:txBody>
@@ -24726,8 +25057,8 @@
         </p:nvSpPr>
         <p:spPr>
           <a:xfrm>
-            <a:off x="777240" y="2084832"/>
-            <a:ext cx="3362858" cy="3456432"/>
+            <a:off x="777240" y="2148840"/>
+            <a:ext cx="3362858" cy="2514600"/>
           </a:xfrm>
           <a:prstGeom prst="roundRect">
             <a:avLst>
@@ -24761,66 +25092,89 @@
       </p:sp>
       <p:sp>
         <p:nvSpPr>
-          <p:cNvPr id="8" name="Puce"/>
-          <p:cNvSpPr/>
-          <p:nvPr/>
-        </p:nvSpPr>
-        <p:spPr>
-          <a:xfrm>
-            <a:off x="1124712" y="2414016"/>
-            <a:ext cx="457200" cy="457200"/>
-          </a:xfrm>
-          <a:prstGeom prst="roundRect">
-            <a:avLst>
-              <a:gd name="adj" fmla="val 20000"/>
-            </a:avLst>
+          <p:cNvPr id="8" name="Liseré"/>
+          <p:cNvSpPr/>
+          <p:nvPr/>
+        </p:nvSpPr>
+        <p:spPr>
+          <a:xfrm>
+            <a:off x="1124712" y="2148840"/>
+            <a:ext cx="50292" cy="2514600"/>
+          </a:xfrm>
+          <a:prstGeom prst="rect">
+            <a:avLst/>
           </a:prstGeom>
           <a:solidFill>
             <a:srgbClr val="5B9DF9">
-              <a:alpha val="15000"/>
+              <a:alpha val="70000"/>
             </a:srgbClr>
           </a:solidFill>
-          <a:ln w="13970" cap="flat" cmpd="sng" algn="ctr">
-            <a:solidFill>
-              <a:srgbClr val="5B9DF9">
-                <a:alpha val="75000"/>
-              </a:srgbClr>
-            </a:solidFill>
-            <a:prstDash val="solid"/>
-          </a:ln>
-        </p:spPr>
-        <p:txBody>
-          <a:bodyPr wrap="square" lIns="0" tIns="0" rIns="0" bIns="0" anchor="ctr">
-            <a:noAutofit/>
-          </a:bodyPr>
-          <a:lstStyle/>
-          <a:p>
-            <a:pPr marL="0" indent="0" algn="ctr">
+          <a:ln>
+            <a:noFill/>
+          </a:ln>
+        </p:spPr>
+        <p:txBody>
+          <a:bodyPr wrap="square" lIns="0" tIns="0" rIns="0" bIns="0" anchor="t">
+            <a:noAutofit/>
+          </a:bodyPr>
+          <a:lstStyle/>
+          <a:p>
+            <a:pPr/>
+            <a:endParaRPr lang="fr-FR"/>
+          </a:p>
+        </p:txBody>
+      </p:sp>
+      <p:sp>
+        <p:nvSpPr>
+          <p:cNvPr id="9" name="Text"/>
+          <p:cNvSpPr/>
+          <p:nvPr/>
+        </p:nvSpPr>
+        <p:spPr>
+          <a:xfrm>
+            <a:off x="1344168" y="2487168"/>
+            <a:ext cx="2448458" cy="365760"/>
+          </a:xfrm>
+          <a:prstGeom prst="rect">
+            <a:avLst/>
+          </a:prstGeom>
+          <a:noFill/>
+          <a:ln>
+            <a:noFill/>
+          </a:ln>
+        </p:spPr>
+        <p:txBody>
+          <a:bodyPr wrap="square" lIns="0" tIns="0" rIns="0" bIns="0" anchor="t">
+            <a:noAutofit/>
+          </a:bodyPr>
+          <a:lstStyle/>
+          <a:p>
+            <a:pPr marL="0" indent="0" algn="l">
               <a:buNone/>
             </a:pPr>
             <a:r>
               <a:rPr lang="fr-FR" sz="1550" dirty="0" b="1">
                 <a:solidFill>
-                  <a:srgbClr val="5B9DF9"/>
-                </a:solidFill>
-                <a:latin typeface="Segoe UI"/>
-                <a:cs typeface="Segoe UI"/>
-              </a:rPr>
-              <a:t>01</a:t>
-            </a:r>
-          </a:p>
-        </p:txBody>
-      </p:sp>
-      <p:sp>
-        <p:nvSpPr>
-          <p:cNvPr id="9" name="Text"/>
-          <p:cNvSpPr/>
-          <p:nvPr/>
-        </p:nvSpPr>
-        <p:spPr>
-          <a:xfrm>
-            <a:off x="1124712" y="3127248"/>
-            <a:ext cx="2667914" cy="332537"/>
+                  <a:srgbClr val="FFFFFF"/>
+                </a:solidFill>
+                <a:latin typeface="Segoe UI"/>
+                <a:cs typeface="Segoe UI"/>
+              </a:rPr>
+              <a:t>Ingénierie &amp; métier</a:t>
+            </a:r>
+          </a:p>
+        </p:txBody>
+      </p:sp>
+      <p:sp>
+        <p:nvSpPr>
+          <p:cNvPr id="10" name="Text"/>
+          <p:cNvSpPr/>
+          <p:nvPr/>
+        </p:nvSpPr>
+        <p:spPr>
+          <a:xfrm>
+            <a:off x="1344168" y="2999232"/>
+            <a:ext cx="2448458" cy="1463040"/>
           </a:xfrm>
           <a:prstGeom prst="rect">
             <a:avLst/>
@@ -24838,63 +25192,55 @@
           <a:p>
             <a:pPr marL="0" indent="0" algn="l">
               <a:lnSpc>
-                <a:spcPct val="112000"/>
+                <a:spcPct val="150000"/>
               </a:lnSpc>
               <a:buNone/>
             </a:pPr>
             <a:r>
-              <a:rPr lang="fr-FR" sz="1650" dirty="0" b="1">
-                <a:solidFill>
-                  <a:srgbClr val="FFFFFF"/>
-                </a:solidFill>
-                <a:latin typeface="Segoe UI"/>
-                <a:cs typeface="Segoe UI"/>
-              </a:rPr>
-              <a:t>Conception &amp; validation</a:t>
-            </a:r>
-          </a:p>
-        </p:txBody>
-      </p:sp>
-      <p:sp>
-        <p:nvSpPr>
-          <p:cNvPr id="10" name="Text"/>
-          <p:cNvSpPr/>
-          <p:nvPr/>
-        </p:nvSpPr>
-        <p:spPr>
-          <a:xfrm>
-            <a:off x="1124712" y="3551225"/>
-            <a:ext cx="2667914" cy="1770583"/>
-          </a:xfrm>
-          <a:prstGeom prst="rect">
-            <a:avLst/>
-          </a:prstGeom>
-          <a:noFill/>
-          <a:ln>
-            <a:noFill/>
-          </a:ln>
-        </p:spPr>
-        <p:txBody>
-          <a:bodyPr wrap="square" lIns="0" tIns="0" rIns="0" bIns="0" anchor="t">
-            <a:noAutofit/>
-          </a:bodyPr>
-          <a:lstStyle/>
+              <a:rPr lang="fr-FR" sz="1200" dirty="0">
+                <a:solidFill>
+                  <a:srgbClr val="9FB6CE"/>
+                </a:solidFill>
+                <a:latin typeface="Segoe UI"/>
+                <a:cs typeface="Segoe UI"/>
+              </a:rPr>
+              <a:t>Capital XC  ·  Capital Logic  ·  Modular XC</a:t>
+            </a:r>
+          </a:p>
           <a:p>
             <a:pPr marL="0" indent="0" algn="l">
               <a:lnSpc>
-                <a:spcPct val="126000"/>
+                <a:spcPct val="150000"/>
               </a:lnSpc>
               <a:buNone/>
             </a:pPr>
             <a:r>
-              <a:rPr lang="fr-FR" sz="1300" dirty="0">
+              <a:rPr lang="fr-FR" sz="1200" dirty="0">
                 <a:solidFill>
                   <a:srgbClr val="9FB6CE"/>
                 </a:solidFill>
                 <a:latin typeface="Segoe UI"/>
                 <a:cs typeface="Segoe UI"/>
               </a:rPr>
-              <a:t>Validation et approbation officielle des plans 2D sous Capital XC et PLM. Plans d'assemblage véhicule et gabarits. Conception des interconnexions.</a:t>
+              <a:t>PLM / ENOVIA V6  ·  Teamcenter</a:t>
+            </a:r>
+          </a:p>
+          <a:p>
+            <a:pPr marL="0" indent="0" algn="l">
+              <a:lnSpc>
+                <a:spcPct val="150000"/>
+              </a:lnSpc>
+              <a:buNone/>
+            </a:pPr>
+            <a:r>
+              <a:rPr lang="fr-FR" sz="1200" dirty="0">
+                <a:solidFill>
+                  <a:srgbClr val="9FB6CE"/>
+                </a:solidFill>
+                <a:latin typeface="Segoe UI"/>
+                <a:cs typeface="Segoe UI"/>
+              </a:rPr>
+              <a:t>CATIA V5 / V6  ·  Schéma unifilaire</a:t>
             </a:r>
           </a:p>
         </p:txBody>
@@ -24907,8 +25253,8 @@
         </p:nvSpPr>
         <p:spPr>
           <a:xfrm>
-            <a:off x="4414418" y="2084832"/>
-            <a:ext cx="3362858" cy="3456432"/>
+            <a:off x="4414418" y="2148840"/>
+            <a:ext cx="3362858" cy="2514600"/>
           </a:xfrm>
           <a:prstGeom prst="roundRect">
             <a:avLst>
@@ -24942,66 +25288,89 @@
       </p:sp>
       <p:sp>
         <p:nvSpPr>
-          <p:cNvPr id="12" name="Puce"/>
-          <p:cNvSpPr/>
-          <p:nvPr/>
-        </p:nvSpPr>
-        <p:spPr>
-          <a:xfrm>
-            <a:off x="4761890" y="2414016"/>
-            <a:ext cx="457200" cy="457200"/>
-          </a:xfrm>
-          <a:prstGeom prst="roundRect">
-            <a:avLst>
-              <a:gd name="adj" fmla="val 20000"/>
-            </a:avLst>
+          <p:cNvPr id="12" name="Liseré"/>
+          <p:cNvSpPr/>
+          <p:nvPr/>
+        </p:nvSpPr>
+        <p:spPr>
+          <a:xfrm>
+            <a:off x="4761890" y="2148840"/>
+            <a:ext cx="50292" cy="2514600"/>
+          </a:xfrm>
+          <a:prstGeom prst="rect">
+            <a:avLst/>
           </a:prstGeom>
           <a:solidFill>
             <a:srgbClr val="34D399">
-              <a:alpha val="15000"/>
+              <a:alpha val="70000"/>
             </a:srgbClr>
           </a:solidFill>
-          <a:ln w="13970" cap="flat" cmpd="sng" algn="ctr">
-            <a:solidFill>
-              <a:srgbClr val="34D399">
-                <a:alpha val="75000"/>
-              </a:srgbClr>
-            </a:solidFill>
-            <a:prstDash val="solid"/>
-          </a:ln>
-        </p:spPr>
-        <p:txBody>
-          <a:bodyPr wrap="square" lIns="0" tIns="0" rIns="0" bIns="0" anchor="ctr">
-            <a:noAutofit/>
-          </a:bodyPr>
-          <a:lstStyle/>
-          <a:p>
-            <a:pPr marL="0" indent="0" algn="ctr">
+          <a:ln>
+            <a:noFill/>
+          </a:ln>
+        </p:spPr>
+        <p:txBody>
+          <a:bodyPr wrap="square" lIns="0" tIns="0" rIns="0" bIns="0" anchor="t">
+            <a:noAutofit/>
+          </a:bodyPr>
+          <a:lstStyle/>
+          <a:p>
+            <a:pPr/>
+            <a:endParaRPr lang="fr-FR"/>
+          </a:p>
+        </p:txBody>
+      </p:sp>
+      <p:sp>
+        <p:nvSpPr>
+          <p:cNvPr id="13" name="Text"/>
+          <p:cNvSpPr/>
+          <p:nvPr/>
+        </p:nvSpPr>
+        <p:spPr>
+          <a:xfrm>
+            <a:off x="4981346" y="2487168"/>
+            <a:ext cx="2448458" cy="365760"/>
+          </a:xfrm>
+          <a:prstGeom prst="rect">
+            <a:avLst/>
+          </a:prstGeom>
+          <a:noFill/>
+          <a:ln>
+            <a:noFill/>
+          </a:ln>
+        </p:spPr>
+        <p:txBody>
+          <a:bodyPr wrap="square" lIns="0" tIns="0" rIns="0" bIns="0" anchor="t">
+            <a:noAutofit/>
+          </a:bodyPr>
+          <a:lstStyle/>
+          <a:p>
+            <a:pPr marL="0" indent="0" algn="l">
               <a:buNone/>
             </a:pPr>
             <a:r>
               <a:rPr lang="fr-FR" sz="1550" dirty="0" b="1">
                 <a:solidFill>
-                  <a:srgbClr val="34D399"/>
-                </a:solidFill>
-                <a:latin typeface="Segoe UI"/>
-                <a:cs typeface="Segoe UI"/>
-              </a:rPr>
-              <a:t>02</a:t>
-            </a:r>
-          </a:p>
-        </p:txBody>
-      </p:sp>
-      <p:sp>
-        <p:nvSpPr>
-          <p:cNvPr id="13" name="Text"/>
-          <p:cNvSpPr/>
-          <p:nvPr/>
-        </p:nvSpPr>
-        <p:spPr>
-          <a:xfrm>
-            <a:off x="4761890" y="3127248"/>
-            <a:ext cx="2667914" cy="332537"/>
+                  <a:srgbClr val="FFFFFF"/>
+                </a:solidFill>
+                <a:latin typeface="Segoe UI"/>
+                <a:cs typeface="Segoe UI"/>
+              </a:rPr>
+              <a:t>Technique &amp; analyse</a:t>
+            </a:r>
+          </a:p>
+        </p:txBody>
+      </p:sp>
+      <p:sp>
+        <p:nvSpPr>
+          <p:cNvPr id="14" name="Text"/>
+          <p:cNvSpPr/>
+          <p:nvPr/>
+        </p:nvSpPr>
+        <p:spPr>
+          <a:xfrm>
+            <a:off x="4981346" y="2999232"/>
+            <a:ext cx="2448458" cy="1463040"/>
           </a:xfrm>
           <a:prstGeom prst="rect">
             <a:avLst/>
@@ -25019,63 +25388,55 @@
           <a:p>
             <a:pPr marL="0" indent="0" algn="l">
               <a:lnSpc>
-                <a:spcPct val="112000"/>
+                <a:spcPct val="150000"/>
               </a:lnSpc>
               <a:buNone/>
             </a:pPr>
             <a:r>
-              <a:rPr lang="fr-FR" sz="1650" dirty="0" b="1">
-                <a:solidFill>
-                  <a:srgbClr val="FFFFFF"/>
-                </a:solidFill>
-                <a:latin typeface="Segoe UI"/>
-                <a:cs typeface="Segoe UI"/>
-              </a:rPr>
-              <a:t>Analyse &amp; ingénierie</a:t>
-            </a:r>
-          </a:p>
-        </p:txBody>
-      </p:sp>
-      <p:sp>
-        <p:nvSpPr>
-          <p:cNvPr id="14" name="Text"/>
-          <p:cNvSpPr/>
-          <p:nvPr/>
-        </p:nvSpPr>
-        <p:spPr>
-          <a:xfrm>
-            <a:off x="4761890" y="3551225"/>
-            <a:ext cx="2667914" cy="1770583"/>
-          </a:xfrm>
-          <a:prstGeom prst="rect">
-            <a:avLst/>
-          </a:prstGeom>
-          <a:noFill/>
-          <a:ln>
-            <a:noFill/>
-          </a:ln>
-        </p:spPr>
-        <p:txBody>
-          <a:bodyPr wrap="square" lIns="0" tIns="0" rIns="0" bIns="0" anchor="t">
-            <a:noAutofit/>
-          </a:bodyPr>
-          <a:lstStyle/>
+              <a:rPr lang="fr-FR" sz="1200" dirty="0">
+                <a:solidFill>
+                  <a:srgbClr val="9FB6CE"/>
+                </a:solidFill>
+                <a:latin typeface="Segoe UI"/>
+                <a:cs typeface="Segoe UI"/>
+              </a:rPr>
+              <a:t>AutoCAD  ·  MATLAB</a:t>
+            </a:r>
+          </a:p>
           <a:p>
             <a:pPr marL="0" indent="0" algn="l">
               <a:lnSpc>
-                <a:spcPct val="126000"/>
+                <a:spcPct val="150000"/>
               </a:lnSpc>
               <a:buNone/>
             </a:pPr>
             <a:r>
-              <a:rPr lang="fr-FR" sz="1300" dirty="0">
+              <a:rPr lang="fr-FR" sz="1200" dirty="0">
                 <a:solidFill>
                   <a:srgbClr val="9FB6CE"/>
                 </a:solidFill>
                 <a:latin typeface="Segoe UI"/>
                 <a:cs typeface="Segoe UI"/>
               </a:rPr>
-              <a:t>Analyse des schémas pour la conception système (SDP). Analyses techniques de production (PTA). Distribution d'énergie et mise à la masse. Études de faisabilité.</a:t>
+              <a:t>Langage C  ·  Programmation</a:t>
+            </a:r>
+          </a:p>
+          <a:p>
+            <a:pPr marL="0" indent="0" algn="l">
+              <a:lnSpc>
+                <a:spcPct val="150000"/>
+              </a:lnSpc>
+              <a:buNone/>
+            </a:pPr>
+            <a:r>
+              <a:rPr lang="fr-FR" sz="1200" dirty="0">
+                <a:solidFill>
+                  <a:srgbClr val="9FB6CE"/>
+                </a:solidFill>
+                <a:latin typeface="Segoe UI"/>
+                <a:cs typeface="Segoe UI"/>
+              </a:rPr>
+              <a:t>Analyse de circuits  ·  Systèmes énergétiques</a:t>
             </a:r>
           </a:p>
         </p:txBody>
@@ -25088,8 +25449,8 @@
         </p:nvSpPr>
         <p:spPr>
           <a:xfrm>
-            <a:off x="8051597" y="2084832"/>
-            <a:ext cx="3362858" cy="3456432"/>
+            <a:off x="8051597" y="2148840"/>
+            <a:ext cx="3362858" cy="2514600"/>
           </a:xfrm>
           <a:prstGeom prst="roundRect">
             <a:avLst>
@@ -25103,7 +25464,7 @@
           </a:solidFill>
           <a:ln w="15875" cap="flat" cmpd="sng" algn="ctr">
             <a:solidFill>
-              <a:srgbClr val="F59E0B">
+              <a:srgbClr val="A78BFA">
                 <a:alpha val="55000"/>
               </a:srgbClr>
             </a:solidFill>
@@ -25123,29 +25484,329 @@
       </p:sp>
       <p:sp>
         <p:nvSpPr>
-          <p:cNvPr id="16" name="Puce"/>
-          <p:cNvSpPr/>
-          <p:nvPr/>
-        </p:nvSpPr>
-        <p:spPr>
-          <a:xfrm>
-            <a:off x="8399069" y="2414016"/>
-            <a:ext cx="457200" cy="457200"/>
+          <p:cNvPr id="16" name="Liseré"/>
+          <p:cNvSpPr/>
+          <p:nvPr/>
+        </p:nvSpPr>
+        <p:spPr>
+          <a:xfrm>
+            <a:off x="8399069" y="2148840"/>
+            <a:ext cx="50292" cy="2514600"/>
+          </a:xfrm>
+          <a:prstGeom prst="rect">
+            <a:avLst/>
+          </a:prstGeom>
+          <a:solidFill>
+            <a:srgbClr val="A78BFA">
+              <a:alpha val="70000"/>
+            </a:srgbClr>
+          </a:solidFill>
+          <a:ln>
+            <a:noFill/>
+          </a:ln>
+        </p:spPr>
+        <p:txBody>
+          <a:bodyPr wrap="square" lIns="0" tIns="0" rIns="0" bIns="0" anchor="t">
+            <a:noAutofit/>
+          </a:bodyPr>
+          <a:lstStyle/>
+          <a:p>
+            <a:pPr/>
+            <a:endParaRPr lang="fr-FR"/>
+          </a:p>
+        </p:txBody>
+      </p:sp>
+      <p:sp>
+        <p:nvSpPr>
+          <p:cNvPr id="17" name="Text"/>
+          <p:cNvSpPr/>
+          <p:nvPr/>
+        </p:nvSpPr>
+        <p:spPr>
+          <a:xfrm>
+            <a:off x="8618525" y="2487168"/>
+            <a:ext cx="2448458" cy="365760"/>
+          </a:xfrm>
+          <a:prstGeom prst="rect">
+            <a:avLst/>
+          </a:prstGeom>
+          <a:noFill/>
+          <a:ln>
+            <a:noFill/>
+          </a:ln>
+        </p:spPr>
+        <p:txBody>
+          <a:bodyPr wrap="square" lIns="0" tIns="0" rIns="0" bIns="0" anchor="t">
+            <a:noAutofit/>
+          </a:bodyPr>
+          <a:lstStyle/>
+          <a:p>
+            <a:pPr marL="0" indent="0" algn="l">
+              <a:buNone/>
+            </a:pPr>
+            <a:r>
+              <a:rPr lang="fr-FR" sz="1550" dirty="0" b="1">
+                <a:solidFill>
+                  <a:srgbClr val="FFFFFF"/>
+                </a:solidFill>
+                <a:latin typeface="Segoe UI"/>
+                <a:cs typeface="Segoe UI"/>
+              </a:rPr>
+              <a:t>Création &amp; développement</a:t>
+            </a:r>
+          </a:p>
+        </p:txBody>
+      </p:sp>
+      <p:sp>
+        <p:nvSpPr>
+          <p:cNvPr id="18" name="Text"/>
+          <p:cNvSpPr/>
+          <p:nvPr/>
+        </p:nvSpPr>
+        <p:spPr>
+          <a:xfrm>
+            <a:off x="8618525" y="2999232"/>
+            <a:ext cx="2448458" cy="1463040"/>
+          </a:xfrm>
+          <a:prstGeom prst="rect">
+            <a:avLst/>
+          </a:prstGeom>
+          <a:noFill/>
+          <a:ln>
+            <a:noFill/>
+          </a:ln>
+        </p:spPr>
+        <p:txBody>
+          <a:bodyPr wrap="square" lIns="0" tIns="0" rIns="0" bIns="0" anchor="t">
+            <a:noAutofit/>
+          </a:bodyPr>
+          <a:lstStyle/>
+          <a:p>
+            <a:pPr marL="0" indent="0" algn="l">
+              <a:lnSpc>
+                <a:spcPct val="150000"/>
+              </a:lnSpc>
+              <a:buNone/>
+            </a:pPr>
+            <a:r>
+              <a:rPr lang="fr-FR" sz="1200" dirty="0">
+                <a:solidFill>
+                  <a:srgbClr val="9FB6CE"/>
+                </a:solidFill>
+                <a:latin typeface="Segoe UI"/>
+                <a:cs typeface="Segoe UI"/>
+              </a:rPr>
+              <a:t>Photoshop  ·  Illustrator</a:t>
+            </a:r>
+          </a:p>
+          <a:p>
+            <a:pPr marL="0" indent="0" algn="l">
+              <a:lnSpc>
+                <a:spcPct val="150000"/>
+              </a:lnSpc>
+              <a:buNone/>
+            </a:pPr>
+            <a:r>
+              <a:rPr lang="fr-FR" sz="1200" dirty="0">
+                <a:solidFill>
+                  <a:srgbClr val="9FB6CE"/>
+                </a:solidFill>
+                <a:latin typeface="Segoe UI"/>
+                <a:cs typeface="Segoe UI"/>
+              </a:rPr>
+              <a:t>Premiere Pro  ·  After Effects</a:t>
+            </a:r>
+          </a:p>
+          <a:p>
+            <a:pPr marL="0" indent="0" algn="l">
+              <a:lnSpc>
+                <a:spcPct val="150000"/>
+              </a:lnSpc>
+              <a:buNone/>
+            </a:pPr>
+            <a:r>
+              <a:rPr lang="fr-FR" sz="1200" dirty="0">
+                <a:solidFill>
+                  <a:srgbClr val="9FB6CE"/>
+                </a:solidFill>
+                <a:latin typeface="Segoe UI"/>
+                <a:cs typeface="Segoe UI"/>
+              </a:rPr>
+              <a:t>Motion graphic  ·  Design  ·  Modélisation 3D</a:t>
+            </a:r>
+          </a:p>
+        </p:txBody>
+      </p:sp>
+      <p:sp>
+        <p:nvSpPr>
+          <p:cNvPr id="19" name="Text"/>
+          <p:cNvSpPr/>
+          <p:nvPr/>
+        </p:nvSpPr>
+        <p:spPr>
+          <a:xfrm>
+            <a:off x="777240" y="4956048"/>
+            <a:ext cx="10637215" cy="274320"/>
+          </a:xfrm>
+          <a:prstGeom prst="rect">
+            <a:avLst/>
+          </a:prstGeom>
+          <a:noFill/>
+          <a:ln>
+            <a:noFill/>
+          </a:ln>
+        </p:spPr>
+        <p:txBody>
+          <a:bodyPr wrap="square" lIns="0" tIns="0" rIns="0" bIns="0" anchor="t">
+            <a:noAutofit/>
+          </a:bodyPr>
+          <a:lstStyle/>
+          <a:p>
+            <a:pPr marL="0" indent="0" algn="ctr">
+              <a:buNone/>
+            </a:pPr>
+            <a:r>
+              <a:rPr lang="fr-FR" sz="1050" dirty="0" b="1" spc="160" cap="all">
+                <a:solidFill>
+                  <a:srgbClr val="6E89A6"/>
+                </a:solidFill>
+                <a:latin typeface="Segoe UI"/>
+                <a:cs typeface="Segoe UI"/>
+              </a:rPr>
+              <a:t>Langues de travail</a:t>
+            </a:r>
+          </a:p>
+        </p:txBody>
+      </p:sp>
+      <p:sp>
+        <p:nvSpPr>
+          <p:cNvPr id="20" name="Pastille"/>
+          <p:cNvSpPr/>
+          <p:nvPr/>
+        </p:nvSpPr>
+        <p:spPr>
+          <a:xfrm>
+            <a:off x="2959456" y="5285232"/>
+            <a:ext cx="2327148" cy="384048"/>
           </a:xfrm>
           <a:prstGeom prst="roundRect">
             <a:avLst>
-              <a:gd name="adj" fmla="val 20000"/>
+              <a:gd name="adj" fmla="val 50000"/>
+            </a:avLst>
+          </a:prstGeom>
+          <a:solidFill>
+            <a:srgbClr val="5B9DF9">
+              <a:alpha val="12000"/>
+            </a:srgbClr>
+          </a:solidFill>
+          <a:ln w="13970" cap="flat" cmpd="sng" algn="ctr">
+            <a:solidFill>
+              <a:srgbClr val="5B9DF9">
+                <a:alpha val="60000"/>
+              </a:srgbClr>
+            </a:solidFill>
+            <a:prstDash val="solid"/>
+          </a:ln>
+        </p:spPr>
+        <p:txBody>
+          <a:bodyPr wrap="square" lIns="0" tIns="0" rIns="0" bIns="0" anchor="ctr">
+            <a:noAutofit/>
+          </a:bodyPr>
+          <a:lstStyle/>
+          <a:p>
+            <a:pPr marL="0" indent="0" algn="ctr">
+              <a:buNone/>
+            </a:pPr>
+            <a:r>
+              <a:rPr lang="fr-FR" sz="1150" dirty="0" b="1">
+                <a:solidFill>
+                  <a:srgbClr val="5B9DF9"/>
+                </a:solidFill>
+                <a:latin typeface="Segoe UI"/>
+                <a:cs typeface="Segoe UI"/>
+              </a:rPr>
+              <a:t>Arabe — langue maternelle</a:t>
+            </a:r>
+          </a:p>
+        </p:txBody>
+      </p:sp>
+      <p:sp>
+        <p:nvSpPr>
+          <p:cNvPr id="21" name="Pastille"/>
+          <p:cNvSpPr/>
+          <p:nvPr/>
+        </p:nvSpPr>
+        <p:spPr>
+          <a:xfrm>
+            <a:off x="5487772" y="5285232"/>
+            <a:ext cx="1808683" cy="384048"/>
+          </a:xfrm>
+          <a:prstGeom prst="roundRect">
+            <a:avLst>
+              <a:gd name="adj" fmla="val 50000"/>
+            </a:avLst>
+          </a:prstGeom>
+          <a:solidFill>
+            <a:srgbClr val="34D399">
+              <a:alpha val="12000"/>
+            </a:srgbClr>
+          </a:solidFill>
+          <a:ln w="13970" cap="flat" cmpd="sng" algn="ctr">
+            <a:solidFill>
+              <a:srgbClr val="34D399">
+                <a:alpha val="60000"/>
+              </a:srgbClr>
+            </a:solidFill>
+            <a:prstDash val="solid"/>
+          </a:ln>
+        </p:spPr>
+        <p:txBody>
+          <a:bodyPr wrap="square" lIns="0" tIns="0" rIns="0" bIns="0" anchor="ctr">
+            <a:noAutofit/>
+          </a:bodyPr>
+          <a:lstStyle/>
+          <a:p>
+            <a:pPr marL="0" indent="0" algn="ctr">
+              <a:buNone/>
+            </a:pPr>
+            <a:r>
+              <a:rPr lang="fr-FR" sz="1150" dirty="0" b="1">
+                <a:solidFill>
+                  <a:srgbClr val="34D399"/>
+                </a:solidFill>
+                <a:latin typeface="Segoe UI"/>
+                <a:cs typeface="Segoe UI"/>
+              </a:rPr>
+              <a:t>Français — courant</a:t>
+            </a:r>
+          </a:p>
+        </p:txBody>
+      </p:sp>
+      <p:sp>
+        <p:nvSpPr>
+          <p:cNvPr id="22" name="Pastille"/>
+          <p:cNvSpPr/>
+          <p:nvPr/>
+        </p:nvSpPr>
+        <p:spPr>
+          <a:xfrm>
+            <a:off x="7497623" y="5285232"/>
+            <a:ext cx="1734617" cy="384048"/>
+          </a:xfrm>
+          <a:prstGeom prst="roundRect">
+            <a:avLst>
+              <a:gd name="adj" fmla="val 50000"/>
             </a:avLst>
           </a:prstGeom>
           <a:solidFill>
             <a:srgbClr val="F59E0B">
-              <a:alpha val="15000"/>
+              <a:alpha val="12000"/>
             </a:srgbClr>
           </a:solidFill>
           <a:ln w="13970" cap="flat" cmpd="sng" algn="ctr">
             <a:solidFill>
               <a:srgbClr val="F59E0B">
-                <a:alpha val="75000"/>
+                <a:alpha val="60000"/>
               </a:srgbClr>
             </a:solidFill>
             <a:prstDash val="solid"/>
@@ -25161,102 +25822,14 @@
               <a:buNone/>
             </a:pPr>
             <a:r>
-              <a:rPr lang="fr-FR" sz="1550" dirty="0" b="1">
+              <a:rPr lang="fr-FR" sz="1150" dirty="0" b="1">
                 <a:solidFill>
                   <a:srgbClr val="F59E0B"/>
                 </a:solidFill>
                 <a:latin typeface="Segoe UI"/>
                 <a:cs typeface="Segoe UI"/>
               </a:rPr>
-              <a:t>03</a:t>
-            </a:r>
-          </a:p>
-        </p:txBody>
-      </p:sp>
-      <p:sp>
-        <p:nvSpPr>
-          <p:cNvPr id="17" name="Text"/>
-          <p:cNvSpPr/>
-          <p:nvPr/>
-        </p:nvSpPr>
-        <p:spPr>
-          <a:xfrm>
-            <a:off x="8399069" y="3127248"/>
-            <a:ext cx="2667914" cy="332537"/>
-          </a:xfrm>
-          <a:prstGeom prst="rect">
-            <a:avLst/>
-          </a:prstGeom>
-          <a:noFill/>
-          <a:ln>
-            <a:noFill/>
-          </a:ln>
-        </p:spPr>
-        <p:txBody>
-          <a:bodyPr wrap="square" lIns="0" tIns="0" rIns="0" bIns="0" anchor="t">
-            <a:noAutofit/>
-          </a:bodyPr>
-          <a:lstStyle/>
-          <a:p>
-            <a:pPr marL="0" indent="0" algn="l">
-              <a:lnSpc>
-                <a:spcPct val="112000"/>
-              </a:lnSpc>
-              <a:buNone/>
-            </a:pPr>
-            <a:r>
-              <a:rPr lang="fr-FR" sz="1650" dirty="0" b="1">
-                <a:solidFill>
-                  <a:srgbClr val="FFFFFF"/>
-                </a:solidFill>
-                <a:latin typeface="Segoe UI"/>
-                <a:cs typeface="Segoe UI"/>
-              </a:rPr>
-              <a:t>Interface &amp; qualité</a:t>
-            </a:r>
-          </a:p>
-        </p:txBody>
-      </p:sp>
-      <p:sp>
-        <p:nvSpPr>
-          <p:cNvPr id="18" name="Text"/>
-          <p:cNvSpPr/>
-          <p:nvPr/>
-        </p:nvSpPr>
-        <p:spPr>
-          <a:xfrm>
-            <a:off x="8399069" y="3551225"/>
-            <a:ext cx="2667914" cy="1770583"/>
-          </a:xfrm>
-          <a:prstGeom prst="rect">
-            <a:avLst/>
-          </a:prstGeom>
-          <a:noFill/>
-          <a:ln>
-            <a:noFill/>
-          </a:ln>
-        </p:spPr>
-        <p:txBody>
-          <a:bodyPr wrap="square" lIns="0" tIns="0" rIns="0" bIns="0" anchor="t">
-            <a:noAutofit/>
-          </a:bodyPr>
-          <a:lstStyle/>
-          <a:p>
-            <a:pPr marL="0" indent="0" algn="l">
-              <a:lnSpc>
-                <a:spcPct val="126000"/>
-              </a:lnSpc>
-              <a:buNone/>
-            </a:pPr>
-            <a:r>
-              <a:rPr lang="fr-FR" sz="1300" dirty="0">
-                <a:solidFill>
-                  <a:srgbClr val="9FB6CE"/>
-                </a:solidFill>
-                <a:latin typeface="Segoe UI"/>
-                <a:cs typeface="Segoe UI"/>
-              </a:rPr>
-              <a:t>Réunions projet avec le client et propositions de solutions. Revue des définitions fournisseurs. Analyse qualité, coûts, délais. Application de la FETE.</a:t>
+              <a:t>Anglais — courant</a:t>
             </a:r>
           </a:p>
         </p:txBody>
@@ -25452,12 +26025,12 @@
             <a:r>
               <a:rPr lang="fr-FR" sz="1150" dirty="0" b="1" spc="190" cap="all">
                 <a:solidFill>
-                  <a:srgbClr val="5B9DF9"/>
-                </a:solidFill>
-                <a:latin typeface="Segoe UI"/>
-                <a:cs typeface="Segoe UI"/>
-              </a:rPr>
-              <a:t>Compétences</a:t>
+                  <a:srgbClr val="34D399"/>
+                </a:solidFill>
+                <a:latin typeface="Segoe UI"/>
+                <a:cs typeface="Segoe UI"/>
+              </a:rPr>
+              <a:t>Mon évolution chez MG2 Engineering</a:t>
             </a:r>
           </a:p>
         </p:txBody>
@@ -25501,7 +26074,7 @@
                 <a:latin typeface="Segoe UI"/>
                 <a:cs typeface="Segoe UI"/>
               </a:rPr>
-              <a:t>Un profil double : métier et numérique</a:t>
+              <a:t>Concevoir, puis transmettre</a:t>
             </a:r>
           </a:p>
         </p:txBody>
@@ -25514,8 +26087,8 @@
         </p:nvSpPr>
         <p:spPr>
           <a:xfrm>
-            <a:off x="777240" y="2148840"/>
-            <a:ext cx="3362858" cy="2514600"/>
+            <a:off x="777240" y="2084832"/>
+            <a:ext cx="3362858" cy="2395728"/>
           </a:xfrm>
           <a:prstGeom prst="roundRect">
             <a:avLst>
@@ -25549,35 +26122,53 @@
       </p:sp>
       <p:sp>
         <p:nvSpPr>
-          <p:cNvPr id="8" name="Liseré"/>
-          <p:cNvSpPr/>
-          <p:nvPr/>
-        </p:nvSpPr>
-        <p:spPr>
-          <a:xfrm>
-            <a:off x="1124712" y="2148840"/>
-            <a:ext cx="50292" cy="2514600"/>
-          </a:xfrm>
-          <a:prstGeom prst="rect">
-            <a:avLst/>
+          <p:cNvPr id="8" name="Puce"/>
+          <p:cNvSpPr/>
+          <p:nvPr/>
+        </p:nvSpPr>
+        <p:spPr>
+          <a:xfrm>
+            <a:off x="1124712" y="2414016"/>
+            <a:ext cx="457200" cy="457200"/>
+          </a:xfrm>
+          <a:prstGeom prst="roundRect">
+            <a:avLst>
+              <a:gd name="adj" fmla="val 20000"/>
+            </a:avLst>
           </a:prstGeom>
           <a:solidFill>
             <a:srgbClr val="5B9DF9">
-              <a:alpha val="70000"/>
+              <a:alpha val="15000"/>
             </a:srgbClr>
           </a:solidFill>
-          <a:ln>
-            <a:noFill/>
-          </a:ln>
-        </p:spPr>
-        <p:txBody>
-          <a:bodyPr wrap="square" lIns="0" tIns="0" rIns="0" bIns="0" anchor="t">
-            <a:noAutofit/>
-          </a:bodyPr>
-          <a:lstStyle/>
-          <a:p>
-            <a:pPr/>
-            <a:endParaRPr lang="fr-FR"/>
+          <a:ln w="13970" cap="flat" cmpd="sng" algn="ctr">
+            <a:solidFill>
+              <a:srgbClr val="5B9DF9">
+                <a:alpha val="75000"/>
+              </a:srgbClr>
+            </a:solidFill>
+            <a:prstDash val="solid"/>
+          </a:ln>
+        </p:spPr>
+        <p:txBody>
+          <a:bodyPr wrap="square" lIns="0" tIns="0" rIns="0" bIns="0" anchor="ctr">
+            <a:noAutofit/>
+          </a:bodyPr>
+          <a:lstStyle/>
+          <a:p>
+            <a:pPr marL="0" indent="0" algn="ctr">
+              <a:buNone/>
+            </a:pPr>
+            <a:r>
+              <a:rPr lang="fr-FR" sz="1550" dirty="0" b="1">
+                <a:solidFill>
+                  <a:srgbClr val="5B9DF9"/>
+                </a:solidFill>
+                <a:latin typeface="Segoe UI"/>
+                <a:cs typeface="Segoe UI"/>
+              </a:rPr>
+              <a:t>01</a:t>
+            </a:r>
           </a:p>
         </p:txBody>
       </p:sp>
@@ -25589,49 +26180,8 @@
         </p:nvSpPr>
         <p:spPr>
           <a:xfrm>
-            <a:off x="1344168" y="2487168"/>
-            <a:ext cx="2448458" cy="365760"/>
-          </a:xfrm>
-          <a:prstGeom prst="rect">
-            <a:avLst/>
-          </a:prstGeom>
-          <a:noFill/>
-          <a:ln>
-            <a:noFill/>
-          </a:ln>
-        </p:spPr>
-        <p:txBody>
-          <a:bodyPr wrap="square" lIns="0" tIns="0" rIns="0" bIns="0" anchor="t">
-            <a:noAutofit/>
-          </a:bodyPr>
-          <a:lstStyle/>
-          <a:p>
-            <a:pPr marL="0" indent="0" algn="l">
-              <a:buNone/>
-            </a:pPr>
-            <a:r>
-              <a:rPr lang="fr-FR" sz="1550" dirty="0" b="1">
-                <a:solidFill>
-                  <a:srgbClr val="FFFFFF"/>
-                </a:solidFill>
-                <a:latin typeface="Segoe UI"/>
-                <a:cs typeface="Segoe UI"/>
-              </a:rPr>
-              <a:t>Ingénierie &amp; métier</a:t>
-            </a:r>
-          </a:p>
-        </p:txBody>
-      </p:sp>
-      <p:sp>
-        <p:nvSpPr>
-          <p:cNvPr id="10" name="Text"/>
-          <p:cNvSpPr/>
-          <p:nvPr/>
-        </p:nvSpPr>
-        <p:spPr>
-          <a:xfrm>
-            <a:off x="1344168" y="2999232"/>
-            <a:ext cx="2448458" cy="1463040"/>
+            <a:off x="1124712" y="3127248"/>
+            <a:ext cx="2667914" cy="323291"/>
           </a:xfrm>
           <a:prstGeom prst="rect">
             <a:avLst/>
@@ -25649,55 +26199,63 @@
           <a:p>
             <a:pPr marL="0" indent="0" algn="l">
               <a:lnSpc>
-                <a:spcPct val="150000"/>
+                <a:spcPct val="112000"/>
               </a:lnSpc>
               <a:buNone/>
             </a:pPr>
             <a:r>
-              <a:rPr lang="fr-FR" sz="1200" dirty="0">
-                <a:solidFill>
-                  <a:srgbClr val="9FB6CE"/>
-                </a:solidFill>
-                <a:latin typeface="Segoe UI"/>
-                <a:cs typeface="Segoe UI"/>
-              </a:rPr>
-              <a:t>Capital XC  ·  Capital Logic  ·  Modular XC</a:t>
-            </a:r>
-          </a:p>
+              <a:rPr lang="fr-FR" sz="1600" dirty="0" b="1">
+                <a:solidFill>
+                  <a:srgbClr val="FFFFFF"/>
+                </a:solidFill>
+                <a:latin typeface="Segoe UI"/>
+                <a:cs typeface="Segoe UI"/>
+              </a:rPr>
+              <a:t>Sujets d'innovation</a:t>
+            </a:r>
+          </a:p>
+        </p:txBody>
+      </p:sp>
+      <p:sp>
+        <p:nvSpPr>
+          <p:cNvPr id="10" name="Text"/>
+          <p:cNvSpPr/>
+          <p:nvPr/>
+        </p:nvSpPr>
+        <p:spPr>
+          <a:xfrm>
+            <a:off x="1124712" y="3541979"/>
+            <a:ext cx="2667914" cy="719125"/>
+          </a:xfrm>
+          <a:prstGeom prst="rect">
+            <a:avLst/>
+          </a:prstGeom>
+          <a:noFill/>
+          <a:ln>
+            <a:noFill/>
+          </a:ln>
+        </p:spPr>
+        <p:txBody>
+          <a:bodyPr wrap="square" lIns="0" tIns="0" rIns="0" bIns="0" anchor="t">
+            <a:noAutofit/>
+          </a:bodyPr>
+          <a:lstStyle/>
           <a:p>
             <a:pPr marL="0" indent="0" algn="l">
               <a:lnSpc>
-                <a:spcPct val="150000"/>
+                <a:spcPct val="126000"/>
               </a:lnSpc>
               <a:buNone/>
             </a:pPr>
             <a:r>
-              <a:rPr lang="fr-FR" sz="1200" dirty="0">
+              <a:rPr lang="fr-FR" sz="1250" dirty="0">
                 <a:solidFill>
                   <a:srgbClr val="9FB6CE"/>
                 </a:solidFill>
                 <a:latin typeface="Segoe UI"/>
                 <a:cs typeface="Segoe UI"/>
               </a:rPr>
-              <a:t>PLM / ENOVIA V6  ·  Teamcenter</a:t>
-            </a:r>
-          </a:p>
-          <a:p>
-            <a:pPr marL="0" indent="0" algn="l">
-              <a:lnSpc>
-                <a:spcPct val="150000"/>
-              </a:lnSpc>
-              <a:buNone/>
-            </a:pPr>
-            <a:r>
-              <a:rPr lang="fr-FR" sz="1200" dirty="0">
-                <a:solidFill>
-                  <a:srgbClr val="9FB6CE"/>
-                </a:solidFill>
-                <a:latin typeface="Segoe UI"/>
-                <a:cs typeface="Segoe UI"/>
-              </a:rPr>
-              <a:t>CATIA V5 / V6  ·  Schéma unifilaire</a:t>
+              <a:t>Proposer et porter des sujets d'innovation pour l'équipe.</a:t>
             </a:r>
           </a:p>
         </p:txBody>
@@ -25710,8 +26268,8 @@
         </p:nvSpPr>
         <p:spPr>
           <a:xfrm>
-            <a:off x="4414418" y="2148840"/>
-            <a:ext cx="3362858" cy="2514600"/>
+            <a:off x="4414418" y="2084832"/>
+            <a:ext cx="3362858" cy="2395728"/>
           </a:xfrm>
           <a:prstGeom prst="roundRect">
             <a:avLst>
@@ -25745,35 +26303,53 @@
       </p:sp>
       <p:sp>
         <p:nvSpPr>
-          <p:cNvPr id="12" name="Liseré"/>
-          <p:cNvSpPr/>
-          <p:nvPr/>
-        </p:nvSpPr>
-        <p:spPr>
-          <a:xfrm>
-            <a:off x="4761890" y="2148840"/>
-            <a:ext cx="50292" cy="2514600"/>
-          </a:xfrm>
-          <a:prstGeom prst="rect">
-            <a:avLst/>
+          <p:cNvPr id="12" name="Puce"/>
+          <p:cNvSpPr/>
+          <p:nvPr/>
+        </p:nvSpPr>
+        <p:spPr>
+          <a:xfrm>
+            <a:off x="4761890" y="2414016"/>
+            <a:ext cx="457200" cy="457200"/>
+          </a:xfrm>
+          <a:prstGeom prst="roundRect">
+            <a:avLst>
+              <a:gd name="adj" fmla="val 20000"/>
+            </a:avLst>
           </a:prstGeom>
           <a:solidFill>
             <a:srgbClr val="34D399">
-              <a:alpha val="70000"/>
+              <a:alpha val="15000"/>
             </a:srgbClr>
           </a:solidFill>
-          <a:ln>
-            <a:noFill/>
-          </a:ln>
-        </p:spPr>
-        <p:txBody>
-          <a:bodyPr wrap="square" lIns="0" tIns="0" rIns="0" bIns="0" anchor="t">
-            <a:noAutofit/>
-          </a:bodyPr>
-          <a:lstStyle/>
-          <a:p>
-            <a:pPr/>
-            <a:endParaRPr lang="fr-FR"/>
+          <a:ln w="13970" cap="flat" cmpd="sng" algn="ctr">
+            <a:solidFill>
+              <a:srgbClr val="34D399">
+                <a:alpha val="75000"/>
+              </a:srgbClr>
+            </a:solidFill>
+            <a:prstDash val="solid"/>
+          </a:ln>
+        </p:spPr>
+        <p:txBody>
+          <a:bodyPr wrap="square" lIns="0" tIns="0" rIns="0" bIns="0" anchor="ctr">
+            <a:noAutofit/>
+          </a:bodyPr>
+          <a:lstStyle/>
+          <a:p>
+            <a:pPr marL="0" indent="0" algn="ctr">
+              <a:buNone/>
+            </a:pPr>
+            <a:r>
+              <a:rPr lang="fr-FR" sz="1550" dirty="0" b="1">
+                <a:solidFill>
+                  <a:srgbClr val="34D399"/>
+                </a:solidFill>
+                <a:latin typeface="Segoe UI"/>
+                <a:cs typeface="Segoe UI"/>
+              </a:rPr>
+              <a:t>02</a:t>
+            </a:r>
           </a:p>
         </p:txBody>
       </p:sp>
@@ -25785,49 +26361,8 @@
         </p:nvSpPr>
         <p:spPr>
           <a:xfrm>
-            <a:off x="4981346" y="2487168"/>
-            <a:ext cx="2448458" cy="365760"/>
-          </a:xfrm>
-          <a:prstGeom prst="rect">
-            <a:avLst/>
-          </a:prstGeom>
-          <a:noFill/>
-          <a:ln>
-            <a:noFill/>
-          </a:ln>
-        </p:spPr>
-        <p:txBody>
-          <a:bodyPr wrap="square" lIns="0" tIns="0" rIns="0" bIns="0" anchor="t">
-            <a:noAutofit/>
-          </a:bodyPr>
-          <a:lstStyle/>
-          <a:p>
-            <a:pPr marL="0" indent="0" algn="l">
-              <a:buNone/>
-            </a:pPr>
-            <a:r>
-              <a:rPr lang="fr-FR" sz="1550" dirty="0" b="1">
-                <a:solidFill>
-                  <a:srgbClr val="FFFFFF"/>
-                </a:solidFill>
-                <a:latin typeface="Segoe UI"/>
-                <a:cs typeface="Segoe UI"/>
-              </a:rPr>
-              <a:t>Technique &amp; analyse</a:t>
-            </a:r>
-          </a:p>
-        </p:txBody>
-      </p:sp>
-      <p:sp>
-        <p:nvSpPr>
-          <p:cNvPr id="14" name="Text"/>
-          <p:cNvSpPr/>
-          <p:nvPr/>
-        </p:nvSpPr>
-        <p:spPr>
-          <a:xfrm>
-            <a:off x="4981346" y="2999232"/>
-            <a:ext cx="2448458" cy="1463040"/>
+            <a:off x="4761890" y="3127248"/>
+            <a:ext cx="2667914" cy="323291"/>
           </a:xfrm>
           <a:prstGeom prst="rect">
             <a:avLst/>
@@ -25845,55 +26380,63 @@
           <a:p>
             <a:pPr marL="0" indent="0" algn="l">
               <a:lnSpc>
-                <a:spcPct val="150000"/>
+                <a:spcPct val="112000"/>
               </a:lnSpc>
               <a:buNone/>
             </a:pPr>
             <a:r>
-              <a:rPr lang="fr-FR" sz="1200" dirty="0">
-                <a:solidFill>
-                  <a:srgbClr val="9FB6CE"/>
-                </a:solidFill>
-                <a:latin typeface="Segoe UI"/>
-                <a:cs typeface="Segoe UI"/>
-              </a:rPr>
-              <a:t>AutoCAD  ·  MATLAB</a:t>
-            </a:r>
-          </a:p>
+              <a:rPr lang="fr-FR" sz="1600" dirty="0" b="1">
+                <a:solidFill>
+                  <a:srgbClr val="FFFFFF"/>
+                </a:solidFill>
+                <a:latin typeface="Segoe UI"/>
+                <a:cs typeface="Segoe UI"/>
+              </a:rPr>
+              <a:t>Accompagnement</a:t>
+            </a:r>
+          </a:p>
+        </p:txBody>
+      </p:sp>
+      <p:sp>
+        <p:nvSpPr>
+          <p:cNvPr id="14" name="Text"/>
+          <p:cNvSpPr/>
+          <p:nvPr/>
+        </p:nvSpPr>
+        <p:spPr>
+          <a:xfrm>
+            <a:off x="4761890" y="3541979"/>
+            <a:ext cx="2667914" cy="719125"/>
+          </a:xfrm>
+          <a:prstGeom prst="rect">
+            <a:avLst/>
+          </a:prstGeom>
+          <a:noFill/>
+          <a:ln>
+            <a:noFill/>
+          </a:ln>
+        </p:spPr>
+        <p:txBody>
+          <a:bodyPr wrap="square" lIns="0" tIns="0" rIns="0" bIns="0" anchor="t">
+            <a:noAutofit/>
+          </a:bodyPr>
+          <a:lstStyle/>
           <a:p>
             <a:pPr marL="0" indent="0" algn="l">
               <a:lnSpc>
-                <a:spcPct val="150000"/>
+                <a:spcPct val="126000"/>
               </a:lnSpc>
               <a:buNone/>
             </a:pPr>
             <a:r>
-              <a:rPr lang="fr-FR" sz="1200" dirty="0">
+              <a:rPr lang="fr-FR" sz="1250" dirty="0">
                 <a:solidFill>
                   <a:srgbClr val="9FB6CE"/>
                 </a:solidFill>
                 <a:latin typeface="Segoe UI"/>
                 <a:cs typeface="Segoe UI"/>
               </a:rPr>
-              <a:t>Langage C  ·  Programmation</a:t>
-            </a:r>
-          </a:p>
-          <a:p>
-            <a:pPr marL="0" indent="0" algn="l">
-              <a:lnSpc>
-                <a:spcPct val="150000"/>
-              </a:lnSpc>
-              <a:buNone/>
-            </a:pPr>
-            <a:r>
-              <a:rPr lang="fr-FR" sz="1200" dirty="0">
-                <a:solidFill>
-                  <a:srgbClr val="9FB6CE"/>
-                </a:solidFill>
-                <a:latin typeface="Segoe UI"/>
-                <a:cs typeface="Segoe UI"/>
-              </a:rPr>
-              <a:t>Analyse de circuits  ·  Systèmes énergétiques</a:t>
+              <a:t>Encadrer des stagiaires et les nouveaux arrivants.</a:t>
             </a:r>
           </a:p>
         </p:txBody>
@@ -25906,8 +26449,8 @@
         </p:nvSpPr>
         <p:spPr>
           <a:xfrm>
-            <a:off x="8051597" y="2148840"/>
-            <a:ext cx="3362858" cy="2514600"/>
+            <a:off x="8051597" y="2084832"/>
+            <a:ext cx="3362858" cy="2395728"/>
           </a:xfrm>
           <a:prstGeom prst="roundRect">
             <a:avLst>
@@ -25941,225 +26484,29 @@
       </p:sp>
       <p:sp>
         <p:nvSpPr>
-          <p:cNvPr id="16" name="Liseré"/>
-          <p:cNvSpPr/>
-          <p:nvPr/>
-        </p:nvSpPr>
-        <p:spPr>
-          <a:xfrm>
-            <a:off x="8399069" y="2148840"/>
-            <a:ext cx="50292" cy="2514600"/>
-          </a:xfrm>
-          <a:prstGeom prst="rect">
-            <a:avLst/>
+          <p:cNvPr id="16" name="Puce"/>
+          <p:cNvSpPr/>
+          <p:nvPr/>
+        </p:nvSpPr>
+        <p:spPr>
+          <a:xfrm>
+            <a:off x="8399069" y="2414016"/>
+            <a:ext cx="457200" cy="457200"/>
+          </a:xfrm>
+          <a:prstGeom prst="roundRect">
+            <a:avLst>
+              <a:gd name="adj" fmla="val 20000"/>
+            </a:avLst>
           </a:prstGeom>
           <a:solidFill>
             <a:srgbClr val="A78BFA">
-              <a:alpha val="70000"/>
-            </a:srgbClr>
-          </a:solidFill>
-          <a:ln>
-            <a:noFill/>
-          </a:ln>
-        </p:spPr>
-        <p:txBody>
-          <a:bodyPr wrap="square" lIns="0" tIns="0" rIns="0" bIns="0" anchor="t">
-            <a:noAutofit/>
-          </a:bodyPr>
-          <a:lstStyle/>
-          <a:p>
-            <a:pPr/>
-            <a:endParaRPr lang="fr-FR"/>
-          </a:p>
-        </p:txBody>
-      </p:sp>
-      <p:sp>
-        <p:nvSpPr>
-          <p:cNvPr id="17" name="Text"/>
-          <p:cNvSpPr/>
-          <p:nvPr/>
-        </p:nvSpPr>
-        <p:spPr>
-          <a:xfrm>
-            <a:off x="8618525" y="2487168"/>
-            <a:ext cx="2448458" cy="365760"/>
-          </a:xfrm>
-          <a:prstGeom prst="rect">
-            <a:avLst/>
-          </a:prstGeom>
-          <a:noFill/>
-          <a:ln>
-            <a:noFill/>
-          </a:ln>
-        </p:spPr>
-        <p:txBody>
-          <a:bodyPr wrap="square" lIns="0" tIns="0" rIns="0" bIns="0" anchor="t">
-            <a:noAutofit/>
-          </a:bodyPr>
-          <a:lstStyle/>
-          <a:p>
-            <a:pPr marL="0" indent="0" algn="l">
-              <a:buNone/>
-            </a:pPr>
-            <a:r>
-              <a:rPr lang="fr-FR" sz="1550" dirty="0" b="1">
-                <a:solidFill>
-                  <a:srgbClr val="FFFFFF"/>
-                </a:solidFill>
-                <a:latin typeface="Segoe UI"/>
-                <a:cs typeface="Segoe UI"/>
-              </a:rPr>
-              <a:t>Création &amp; développement</a:t>
-            </a:r>
-          </a:p>
-        </p:txBody>
-      </p:sp>
-      <p:sp>
-        <p:nvSpPr>
-          <p:cNvPr id="18" name="Text"/>
-          <p:cNvSpPr/>
-          <p:nvPr/>
-        </p:nvSpPr>
-        <p:spPr>
-          <a:xfrm>
-            <a:off x="8618525" y="2999232"/>
-            <a:ext cx="2448458" cy="1463040"/>
-          </a:xfrm>
-          <a:prstGeom prst="rect">
-            <a:avLst/>
-          </a:prstGeom>
-          <a:noFill/>
-          <a:ln>
-            <a:noFill/>
-          </a:ln>
-        </p:spPr>
-        <p:txBody>
-          <a:bodyPr wrap="square" lIns="0" tIns="0" rIns="0" bIns="0" anchor="t">
-            <a:noAutofit/>
-          </a:bodyPr>
-          <a:lstStyle/>
-          <a:p>
-            <a:pPr marL="0" indent="0" algn="l">
-              <a:lnSpc>
-                <a:spcPct val="150000"/>
-              </a:lnSpc>
-              <a:buNone/>
-            </a:pPr>
-            <a:r>
-              <a:rPr lang="fr-FR" sz="1200" dirty="0">
-                <a:solidFill>
-                  <a:srgbClr val="9FB6CE"/>
-                </a:solidFill>
-                <a:latin typeface="Segoe UI"/>
-                <a:cs typeface="Segoe UI"/>
-              </a:rPr>
-              <a:t>Photoshop  ·  Illustrator</a:t>
-            </a:r>
-          </a:p>
-          <a:p>
-            <a:pPr marL="0" indent="0" algn="l">
-              <a:lnSpc>
-                <a:spcPct val="150000"/>
-              </a:lnSpc>
-              <a:buNone/>
-            </a:pPr>
-            <a:r>
-              <a:rPr lang="fr-FR" sz="1200" dirty="0">
-                <a:solidFill>
-                  <a:srgbClr val="9FB6CE"/>
-                </a:solidFill>
-                <a:latin typeface="Segoe UI"/>
-                <a:cs typeface="Segoe UI"/>
-              </a:rPr>
-              <a:t>Premiere Pro  ·  After Effects</a:t>
-            </a:r>
-          </a:p>
-          <a:p>
-            <a:pPr marL="0" indent="0" algn="l">
-              <a:lnSpc>
-                <a:spcPct val="150000"/>
-              </a:lnSpc>
-              <a:buNone/>
-            </a:pPr>
-            <a:r>
-              <a:rPr lang="fr-FR" sz="1200" dirty="0">
-                <a:solidFill>
-                  <a:srgbClr val="9FB6CE"/>
-                </a:solidFill>
-                <a:latin typeface="Segoe UI"/>
-                <a:cs typeface="Segoe UI"/>
-              </a:rPr>
-              <a:t>Motion graphic  ·  Design  ·  Modélisation 3D</a:t>
-            </a:r>
-          </a:p>
-        </p:txBody>
-      </p:sp>
-      <p:sp>
-        <p:nvSpPr>
-          <p:cNvPr id="19" name="Text"/>
-          <p:cNvSpPr/>
-          <p:nvPr/>
-        </p:nvSpPr>
-        <p:spPr>
-          <a:xfrm>
-            <a:off x="777240" y="4956048"/>
-            <a:ext cx="10637215" cy="274320"/>
-          </a:xfrm>
-          <a:prstGeom prst="rect">
-            <a:avLst/>
-          </a:prstGeom>
-          <a:noFill/>
-          <a:ln>
-            <a:noFill/>
-          </a:ln>
-        </p:spPr>
-        <p:txBody>
-          <a:bodyPr wrap="square" lIns="0" tIns="0" rIns="0" bIns="0" anchor="t">
-            <a:noAutofit/>
-          </a:bodyPr>
-          <a:lstStyle/>
-          <a:p>
-            <a:pPr marL="0" indent="0" algn="ctr">
-              <a:buNone/>
-            </a:pPr>
-            <a:r>
-              <a:rPr lang="fr-FR" sz="1050" dirty="0" b="1" spc="160" cap="all">
-                <a:solidFill>
-                  <a:srgbClr val="6E89A6"/>
-                </a:solidFill>
-                <a:latin typeface="Segoe UI"/>
-                <a:cs typeface="Segoe UI"/>
-              </a:rPr>
-              <a:t>Langues de travail</a:t>
-            </a:r>
-          </a:p>
-        </p:txBody>
-      </p:sp>
-      <p:sp>
-        <p:nvSpPr>
-          <p:cNvPr id="20" name="Pastille"/>
-          <p:cNvSpPr/>
-          <p:nvPr/>
-        </p:nvSpPr>
-        <p:spPr>
-          <a:xfrm>
-            <a:off x="2959456" y="5285232"/>
-            <a:ext cx="2327148" cy="384048"/>
-          </a:xfrm>
-          <a:prstGeom prst="roundRect">
-            <a:avLst>
-              <a:gd name="adj" fmla="val 50000"/>
-            </a:avLst>
-          </a:prstGeom>
-          <a:solidFill>
-            <a:srgbClr val="5B9DF9">
-              <a:alpha val="12000"/>
+              <a:alpha val="15000"/>
             </a:srgbClr>
           </a:solidFill>
           <a:ln w="13970" cap="flat" cmpd="sng" algn="ctr">
             <a:solidFill>
-              <a:srgbClr val="5B9DF9">
-                <a:alpha val="60000"/>
+              <a:srgbClr val="A78BFA">
+                <a:alpha val="75000"/>
               </a:srgbClr>
             </a:solidFill>
             <a:prstDash val="solid"/>
@@ -26175,50 +26522,138 @@
               <a:buNone/>
             </a:pPr>
             <a:r>
-              <a:rPr lang="fr-FR" sz="1150" dirty="0" b="1">
-                <a:solidFill>
-                  <a:srgbClr val="5B9DF9"/>
-                </a:solidFill>
-                <a:latin typeface="Segoe UI"/>
-                <a:cs typeface="Segoe UI"/>
-              </a:rPr>
-              <a:t>Arabe — langue maternelle</a:t>
-            </a:r>
-          </a:p>
-        </p:txBody>
-      </p:sp>
-      <p:sp>
-        <p:nvSpPr>
-          <p:cNvPr id="21" name="Pastille"/>
-          <p:cNvSpPr/>
-          <p:nvPr/>
-        </p:nvSpPr>
-        <p:spPr>
-          <a:xfrm>
-            <a:off x="5487772" y="5285232"/>
-            <a:ext cx="1808683" cy="384048"/>
+              <a:rPr lang="fr-FR" sz="1550" dirty="0" b="1">
+                <a:solidFill>
+                  <a:srgbClr val="A78BFA"/>
+                </a:solidFill>
+                <a:latin typeface="Segoe UI"/>
+                <a:cs typeface="Segoe UI"/>
+              </a:rPr>
+              <a:t>03</a:t>
+            </a:r>
+          </a:p>
+        </p:txBody>
+      </p:sp>
+      <p:sp>
+        <p:nvSpPr>
+          <p:cNvPr id="17" name="Text"/>
+          <p:cNvSpPr/>
+          <p:nvPr/>
+        </p:nvSpPr>
+        <p:spPr>
+          <a:xfrm>
+            <a:off x="8399069" y="3127248"/>
+            <a:ext cx="2667914" cy="323291"/>
+          </a:xfrm>
+          <a:prstGeom prst="rect">
+            <a:avLst/>
+          </a:prstGeom>
+          <a:noFill/>
+          <a:ln>
+            <a:noFill/>
+          </a:ln>
+        </p:spPr>
+        <p:txBody>
+          <a:bodyPr wrap="square" lIns="0" tIns="0" rIns="0" bIns="0" anchor="t">
+            <a:noAutofit/>
+          </a:bodyPr>
+          <a:lstStyle/>
+          <a:p>
+            <a:pPr marL="0" indent="0" algn="l">
+              <a:lnSpc>
+                <a:spcPct val="112000"/>
+              </a:lnSpc>
+              <a:buNone/>
+            </a:pPr>
+            <a:r>
+              <a:rPr lang="fr-FR" sz="1600" dirty="0" b="1">
+                <a:solidFill>
+                  <a:srgbClr val="FFFFFF"/>
+                </a:solidFill>
+                <a:latin typeface="Segoe UI"/>
+                <a:cs typeface="Segoe UI"/>
+              </a:rPr>
+              <a:t>Formations 2D</a:t>
+            </a:r>
+          </a:p>
+        </p:txBody>
+      </p:sp>
+      <p:sp>
+        <p:nvSpPr>
+          <p:cNvPr id="18" name="Text"/>
+          <p:cNvSpPr/>
+          <p:nvPr/>
+        </p:nvSpPr>
+        <p:spPr>
+          <a:xfrm>
+            <a:off x="8399069" y="3541979"/>
+            <a:ext cx="2667914" cy="719125"/>
+          </a:xfrm>
+          <a:prstGeom prst="rect">
+            <a:avLst/>
+          </a:prstGeom>
+          <a:noFill/>
+          <a:ln>
+            <a:noFill/>
+          </a:ln>
+        </p:spPr>
+        <p:txBody>
+          <a:bodyPr wrap="square" lIns="0" tIns="0" rIns="0" bIns="0" anchor="t">
+            <a:noAutofit/>
+          </a:bodyPr>
+          <a:lstStyle/>
+          <a:p>
+            <a:pPr marL="0" indent="0" algn="l">
+              <a:lnSpc>
+                <a:spcPct val="126000"/>
+              </a:lnSpc>
+              <a:buNone/>
+            </a:pPr>
+            <a:r>
+              <a:rPr lang="fr-FR" sz="1250" dirty="0">
+                <a:solidFill>
+                  <a:srgbClr val="9FB6CE"/>
+                </a:solidFill>
+                <a:latin typeface="Segoe UI"/>
+                <a:cs typeface="Segoe UI"/>
+              </a:rPr>
+              <a:t>Animer les formations de l'équipe 2D, surtout sur Capital XC.</a:t>
+            </a:r>
+          </a:p>
+        </p:txBody>
+      </p:sp>
+      <p:sp>
+        <p:nvSpPr>
+          <p:cNvPr id="19" name="Bandeau"/>
+          <p:cNvSpPr/>
+          <p:nvPr/>
+        </p:nvSpPr>
+        <p:spPr>
+          <a:xfrm>
+            <a:off x="777240" y="4663440"/>
+            <a:ext cx="10637215" cy="1481328"/>
           </a:xfrm>
           <a:prstGeom prst="roundRect">
             <a:avLst>
-              <a:gd name="adj" fmla="val 50000"/>
+              <a:gd name="adj" fmla="val 6000"/>
             </a:avLst>
           </a:prstGeom>
           <a:solidFill>
-            <a:srgbClr val="34D399">
-              <a:alpha val="12000"/>
+            <a:srgbClr val="22D3EE">
+              <a:alpha val="8000"/>
             </a:srgbClr>
           </a:solidFill>
-          <a:ln w="13970" cap="flat" cmpd="sng" algn="ctr">
+          <a:ln w="16510" cap="flat" cmpd="sng" algn="ctr">
             <a:solidFill>
-              <a:srgbClr val="34D399">
-                <a:alpha val="60000"/>
+              <a:srgbClr val="22D3EE">
+                <a:alpha val="45000"/>
               </a:srgbClr>
             </a:solidFill>
             <a:prstDash val="solid"/>
           </a:ln>
         </p:spPr>
         <p:txBody>
-          <a:bodyPr wrap="square" lIns="0" tIns="0" rIns="0" bIns="0" anchor="ctr">
+          <a:bodyPr wrap="square" lIns="548640" tIns="146304" rIns="548640" bIns="146304" anchor="ctr">
             <a:noAutofit/>
           </a:bodyPr>
           <a:lstStyle/>
@@ -26227,66 +26662,53 @@
               <a:buNone/>
             </a:pPr>
             <a:r>
-              <a:rPr lang="fr-FR" sz="1150" dirty="0" b="1">
-                <a:solidFill>
-                  <a:srgbClr val="34D399"/>
-                </a:solidFill>
-                <a:latin typeface="Segoe UI"/>
-                <a:cs typeface="Segoe UI"/>
-              </a:rPr>
-              <a:t>Français — courant</a:t>
-            </a:r>
-          </a:p>
-        </p:txBody>
-      </p:sp>
-      <p:sp>
-        <p:nvSpPr>
-          <p:cNvPr id="22" name="Pastille"/>
-          <p:cNvSpPr/>
-          <p:nvPr/>
-        </p:nvSpPr>
-        <p:spPr>
-          <a:xfrm>
-            <a:off x="7497623" y="5285232"/>
-            <a:ext cx="1734617" cy="384048"/>
-          </a:xfrm>
-          <a:prstGeom prst="roundRect">
-            <a:avLst>
-              <a:gd name="adj" fmla="val 50000"/>
-            </a:avLst>
-          </a:prstGeom>
-          <a:solidFill>
-            <a:srgbClr val="F59E0B">
-              <a:alpha val="12000"/>
-            </a:srgbClr>
-          </a:solidFill>
-          <a:ln w="13970" cap="flat" cmpd="sng" algn="ctr">
-            <a:solidFill>
-              <a:srgbClr val="F59E0B">
-                <a:alpha val="60000"/>
-              </a:srgbClr>
-            </a:solidFill>
-            <a:prstDash val="solid"/>
-          </a:ln>
-        </p:spPr>
-        <p:txBody>
-          <a:bodyPr wrap="square" lIns="0" tIns="0" rIns="0" bIns="0" anchor="ctr">
-            <a:noAutofit/>
-          </a:bodyPr>
-          <a:lstStyle/>
+              <a:rPr lang="fr-FR" sz="1000" dirty="0" b="1" spc="180" cap="all">
+                <a:solidFill>
+                  <a:srgbClr val="22D3EE"/>
+                </a:solidFill>
+                <a:latin typeface="Segoe UI"/>
+                <a:cs typeface="Segoe UI"/>
+              </a:rPr>
+              <a:t>Le constat</a:t>
+            </a:r>
+          </a:p>
           <a:p>
             <a:pPr marL="0" indent="0" algn="ctr">
-              <a:buNone/>
-            </a:pPr>
-            <a:r>
-              <a:rPr lang="fr-FR" sz="1150" dirty="0" b="1">
-                <a:solidFill>
-                  <a:srgbClr val="F59E0B"/>
-                </a:solidFill>
-                <a:latin typeface="Segoe UI"/>
-                <a:cs typeface="Segoe UI"/>
-              </a:rPr>
-              <a:t>Anglais — courant</a:t>
+              <a:lnSpc>
+                <a:spcPct val="135000"/>
+              </a:lnSpc>
+              <a:spcBef>
+                <a:spcPts val="600"/>
+              </a:spcBef>
+              <a:buNone/>
+            </a:pPr>
+            <a:r>
+              <a:rPr lang="fr-FR" sz="1250" dirty="0">
+                <a:solidFill>
+                  <a:srgbClr val="9FB6CE"/>
+                </a:solidFill>
+                <a:latin typeface="Segoe UI"/>
+                <a:cs typeface="Segoe UI"/>
+              </a:rPr>
+              <a:t>Un nouvel arrivant doit apprendre beaucoup de choses en peu de temps : les bases du métier, Capital XC, les méthodes de travail et l'environnement du projet.</a:t>
+            </a:r>
+          </a:p>
+          <a:p>
+            <a:pPr marL="0" indent="0" algn="ctr">
+              <a:spcBef>
+                <a:spcPts val="800"/>
+              </a:spcBef>
+              <a:buNone/>
+            </a:pPr>
+            <a:r>
+              <a:rPr lang="fr-FR" sz="1500" dirty="0" b="1">
+                <a:solidFill>
+                  <a:srgbClr val="FFFFFF"/>
+                </a:solidFill>
+                <a:latin typeface="Segoe UI"/>
+                <a:cs typeface="Segoe UI"/>
+              </a:rPr>
+              <a:t>C'est de ce constat qu'est né KATATOOL.</a:t>
             </a:r>
           </a:p>
         </p:txBody>

</xml_diff>

<commit_message>
Ajout de la Licence 2025 et du Master 2026 au parcours academique
- Diapo 4 : les 5 diplomes en timeline verticale compacte, Master marque 'en cours de validation'
- Diapo 5 : refondue en timeline verticale 5 etapes avec les etablissements
- Discours : nouvelle phrase de bascule 'c'est ce master que je viens valider devant vous aujourd'hui'
- Rebalance a 960 mots -> 7 min 56 s (sous 9 min meme a 115 mots/min)
</commit_message>
<xml_diff>
--- a/soutenance/KATATOOL_Soutenance_Youssef_OUBELLA.pptx
+++ b/soutenance/KATATOOL_Soutenance_Youssef_OUBELLA.pptx
@@ -2227,7 +2227,7 @@
             <a:pPr/>
             <a:r>
               <a:rPr lang="fr-FR" dirty="0"/>
-              <a:t>Mon parcours a commencé dans le domaine scientifique : Baccalauréat Sciences Mathématiques A en 2018 à Taroudant, puis Baccalauréat Sciences et Technologies en 2021 à Agadir.</a:t>
+              <a:t>Mon parcours a commencé dans le domaine scientifique : Baccalauréat Sciences Mathématiques A en 2018, puis Baccalauréat Sciences et Technologies en 2021.</a:t>
             </a:r>
           </a:p>
           <a:p>
@@ -2241,7 +2241,21 @@
             <a:pPr/>
             <a:r>
               <a:rPr lang="fr-FR" dirty="0"/>
-              <a:t>Déroulez la colonne de droite de haut en bas. Si le temps presse, ne citez pas les noms de lycées en entier.</a:t>
+              <a:t>J'ai continué en parallèle de mon travail : Licence en Ingénierie de la Production Industrielle et Gestion de Projet en 2025, puis le Master en Ingénierie et Management Industriel — celui que je viens valider aujourd'hui devant vous.</a:t>
+            </a:r>
+          </a:p>
+          <a:p>
+            <a:pPr/>
+            <a:r>
+              <a:rPr lang="fr-FR" dirty="0"/>
+              <a:t>CETTE DERNIÈRE PHRASE EST FORTE : elle relie votre parcours à ce moment précis. Marquez un temps après.</a:t>
+            </a:r>
+          </a:p>
+          <a:p>
+            <a:pPr/>
+            <a:r>
+              <a:rPr lang="fr-FR" dirty="0"/>
+              <a:t>Déroulez la colonne de droite de haut en bas, sans citer les noms de lycées.</a:t>
             </a:r>
           </a:p>
         </p:txBody>
@@ -2301,14 +2315,21 @@
             <a:pPr/>
             <a:r>
               <a:rPr lang="fr-FR" dirty="0"/>
-              <a:t>À garder sous la main : si un membre du jury demande un détail sur la formation, affichez-la pendant les questions.</a:t>
+              <a:t>À garder sous la main : si le jury demande un détail sur la formation, ou sur le master en cours, affichez-la pendant les questions.</a:t>
             </a:r>
           </a:p>
           <a:p>
             <a:pPr/>
             <a:r>
               <a:rPr lang="fr-FR" dirty="0"/>
-              <a:t>Le parcours académique est déjà résumé sur la diapo 4.</a:t>
+              <a:t>Les cinq diplômes sont déjà résumés sur la diapo 4 — ici s'ajoutent les établissements.</a:t>
+            </a:r>
+          </a:p>
+          <a:p>
+            <a:pPr/>
+            <a:r>
+              <a:rPr lang="fr-FR" dirty="0"/>
+              <a:t>À COMPLÉTER : les établissements de la Licence 2025 et du Master 2026.</a:t>
             </a:r>
           </a:p>
         </p:txBody>
@@ -22469,7 +22490,7 @@
         <p:spPr>
           <a:xfrm>
             <a:off x="777240" y="2084832"/>
-            <a:ext cx="2788920" cy="3931920"/>
+            <a:ext cx="2788920" cy="4041648"/>
           </a:xfrm>
           <a:prstGeom prst="roundRect">
             <a:avLst>
@@ -22603,7 +22624,7 @@
         <p:spPr>
           <a:xfrm>
             <a:off x="4069080" y="3145536"/>
-            <a:ext cx="7162495" cy="960120"/>
+            <a:ext cx="7162495" cy="713232"/>
           </a:xfrm>
           <a:prstGeom prst="rect">
             <a:avLst/>
@@ -22633,7 +22654,7 @@
                 <a:latin typeface="Segoe UI"/>
                 <a:cs typeface="Segoe UI"/>
               </a:rPr>
-              <a:t>Passionné par l'électricité et par la conception de faisceaux : analyse des circuits, systèmes énergétiques, électronique. Un parcours entièrement scientifique et technique.</a:t>
+              <a:t>Passionné par l'électricité et par la conception de faisceaux, et formé en parallèle à l'ingénierie et au management industriel.</a:t>
             </a:r>
           </a:p>
         </p:txBody>
@@ -22646,7 +22667,7 @@
         </p:nvSpPr>
         <p:spPr>
           <a:xfrm>
-            <a:off x="4069080" y="4224528"/>
+            <a:off x="4069080" y="4023360"/>
             <a:ext cx="7345375" cy="274320"/>
           </a:xfrm>
           <a:prstGeom prst="rect">
@@ -22687,8 +22708,8 @@
         </p:nvSpPr>
         <p:spPr>
           <a:xfrm>
-            <a:off x="4892040" y="4700016"/>
-            <a:ext cx="20117" cy="1133856"/>
+            <a:off x="4855464" y="4517136"/>
+            <a:ext cx="20117" cy="1426464"/>
           </a:xfrm>
           <a:prstGeom prst="rect">
             <a:avLst/>
@@ -22719,8 +22740,8 @@
         </p:nvSpPr>
         <p:spPr>
           <a:xfrm>
-            <a:off x="4069080" y="4535424"/>
-            <a:ext cx="713232" cy="457200"/>
+            <a:off x="4069080" y="4389120"/>
+            <a:ext cx="658368" cy="310896"/>
           </a:xfrm>
           <a:prstGeom prst="rect">
             <a:avLst/>
@@ -22740,7 +22761,7 @@
               <a:buNone/>
             </a:pPr>
             <a:r>
-              <a:rPr lang="fr-FR" sz="1250" dirty="0" b="1">
+              <a:rPr lang="fr-FR" sz="1200" dirty="0" b="1">
                 <a:solidFill>
                   <a:srgbClr val="5B9DF9"/>
                 </a:solidFill>
@@ -22760,7 +22781,7 @@
         </p:nvSpPr>
         <p:spPr>
           <a:xfrm>
-            <a:off x="4841748" y="4709160"/>
+            <a:off x="4807915" y="4485132"/>
             <a:ext cx="118872" cy="118872"/>
           </a:xfrm>
           <a:prstGeom prst="ellipse">
@@ -22795,8 +22816,8 @@
         </p:nvSpPr>
         <p:spPr>
           <a:xfrm>
-            <a:off x="5120640" y="4535424"/>
-            <a:ext cx="6293815" cy="457200"/>
+            <a:off x="5056632" y="4389120"/>
+            <a:ext cx="6357823" cy="310896"/>
           </a:xfrm>
           <a:prstGeom prst="rect">
             <a:avLst/>
@@ -22816,7 +22837,7 @@
               <a:buNone/>
             </a:pPr>
             <a:r>
-              <a:rPr lang="fr-FR" sz="1250" dirty="0" b="1">
+              <a:rPr lang="fr-FR" sz="1200" dirty="0" b="1">
                 <a:solidFill>
                   <a:srgbClr val="FFFFFF"/>
                 </a:solidFill>
@@ -22826,24 +22847,6 @@
               <a:t>Baccalauréat Sciences Mathématiques A</a:t>
             </a:r>
           </a:p>
-          <a:p>
-            <a:pPr marL="0" indent="0" algn="l">
-              <a:spcBef>
-                <a:spcPts val="200"/>
-              </a:spcBef>
-              <a:buNone/>
-            </a:pPr>
-            <a:r>
-              <a:rPr lang="fr-FR" sz="1050" dirty="0">
-                <a:solidFill>
-                  <a:srgbClr val="9FB6CE"/>
-                </a:solidFill>
-                <a:latin typeface="Segoe UI"/>
-                <a:cs typeface="Segoe UI"/>
-              </a:rPr>
-              <a:t>Lycée Ibn Soulaiman Roudani — Taroudant</a:t>
-            </a:r>
-          </a:p>
         </p:txBody>
       </p:sp>
       <p:sp>
@@ -22854,8 +22857,8 @@
         </p:nvSpPr>
         <p:spPr>
           <a:xfrm>
-            <a:off x="4069080" y="5038344"/>
-            <a:ext cx="713232" cy="457200"/>
+            <a:off x="4069080" y="4745736"/>
+            <a:ext cx="658368" cy="310896"/>
           </a:xfrm>
           <a:prstGeom prst="rect">
             <a:avLst/>
@@ -22875,7 +22878,7 @@
               <a:buNone/>
             </a:pPr>
             <a:r>
-              <a:rPr lang="fr-FR" sz="1250" dirty="0" b="1">
+              <a:rPr lang="fr-FR" sz="1200" dirty="0" b="1">
                 <a:solidFill>
                   <a:srgbClr val="22D3EE"/>
                 </a:solidFill>
@@ -22895,7 +22898,7 @@
         </p:nvSpPr>
         <p:spPr>
           <a:xfrm>
-            <a:off x="4841748" y="5212080"/>
+            <a:off x="4807915" y="4841748"/>
             <a:ext cx="118872" cy="118872"/>
           </a:xfrm>
           <a:prstGeom prst="ellipse">
@@ -22930,8 +22933,8 @@
         </p:nvSpPr>
         <p:spPr>
           <a:xfrm>
-            <a:off x="5120640" y="5038344"/>
-            <a:ext cx="6293815" cy="457200"/>
+            <a:off x="5056632" y="4745736"/>
+            <a:ext cx="6357823" cy="310896"/>
           </a:xfrm>
           <a:prstGeom prst="rect">
             <a:avLst/>
@@ -22951,7 +22954,7 @@
               <a:buNone/>
             </a:pPr>
             <a:r>
-              <a:rPr lang="fr-FR" sz="1250" dirty="0" b="1">
+              <a:rPr lang="fr-FR" sz="1200" dirty="0" b="1">
                 <a:solidFill>
                   <a:srgbClr val="FFFFFF"/>
                 </a:solidFill>
@@ -22961,24 +22964,6 @@
               <a:t>Baccalauréat Sciences et Technologies</a:t>
             </a:r>
           </a:p>
-          <a:p>
-            <a:pPr marL="0" indent="0" algn="l">
-              <a:spcBef>
-                <a:spcPts val="200"/>
-              </a:spcBef>
-              <a:buNone/>
-            </a:pPr>
-            <a:r>
-              <a:rPr lang="fr-FR" sz="1050" dirty="0">
-                <a:solidFill>
-                  <a:srgbClr val="9FB6CE"/>
-                </a:solidFill>
-                <a:latin typeface="Segoe UI"/>
-                <a:cs typeface="Segoe UI"/>
-              </a:rPr>
-              <a:t>Lycée Al Inbiaat — Agadir</a:t>
-            </a:r>
-          </a:p>
         </p:txBody>
       </p:sp>
       <p:sp>
@@ -22989,8 +22974,8 @@
         </p:nvSpPr>
         <p:spPr>
           <a:xfrm>
-            <a:off x="4069080" y="5541264"/>
-            <a:ext cx="713232" cy="457200"/>
+            <a:off x="4069080" y="5102352"/>
+            <a:ext cx="658368" cy="310896"/>
           </a:xfrm>
           <a:prstGeom prst="rect">
             <a:avLst/>
@@ -23010,7 +22995,7 @@
               <a:buNone/>
             </a:pPr>
             <a:r>
-              <a:rPr lang="fr-FR" sz="1250" dirty="0" b="1">
+              <a:rPr lang="fr-FR" sz="1200" dirty="0" b="1">
                 <a:solidFill>
                   <a:srgbClr val="34D399"/>
                 </a:solidFill>
@@ -23030,7 +23015,7 @@
         </p:nvSpPr>
         <p:spPr>
           <a:xfrm>
-            <a:off x="4841748" y="5715000"/>
+            <a:off x="4807915" y="5198364"/>
             <a:ext cx="118872" cy="118872"/>
           </a:xfrm>
           <a:prstGeom prst="ellipse">
@@ -23065,8 +23050,8 @@
         </p:nvSpPr>
         <p:spPr>
           <a:xfrm>
-            <a:off x="5120640" y="5541264"/>
-            <a:ext cx="6293815" cy="457200"/>
+            <a:off x="5056632" y="5102352"/>
+            <a:ext cx="6357823" cy="310896"/>
           </a:xfrm>
           <a:prstGeom prst="rect">
             <a:avLst/>
@@ -23086,7 +23071,7 @@
               <a:buNone/>
             </a:pPr>
             <a:r>
-              <a:rPr lang="fr-FR" sz="1250" dirty="0" b="1">
+              <a:rPr lang="fr-FR" sz="1200" dirty="0" b="1">
                 <a:solidFill>
                   <a:srgbClr val="FFFFFF"/>
                 </a:solidFill>
@@ -23096,22 +23081,248 @@
               <a:t>DUT Génie Électrique</a:t>
             </a:r>
           </a:p>
+        </p:txBody>
+      </p:sp>
+      <p:sp>
+        <p:nvSpPr>
+          <p:cNvPr id="22" name="Text"/>
+          <p:cNvSpPr/>
+          <p:nvPr/>
+        </p:nvSpPr>
+        <p:spPr>
+          <a:xfrm>
+            <a:off x="4069080" y="5458968"/>
+            <a:ext cx="658368" cy="310896"/>
+          </a:xfrm>
+          <a:prstGeom prst="rect">
+            <a:avLst/>
+          </a:prstGeom>
+          <a:noFill/>
+          <a:ln>
+            <a:noFill/>
+          </a:ln>
+        </p:spPr>
+        <p:txBody>
+          <a:bodyPr wrap="square" lIns="0" tIns="0" rIns="0" bIns="0" anchor="ctr">
+            <a:noAutofit/>
+          </a:bodyPr>
+          <a:lstStyle/>
+          <a:p>
+            <a:pPr marL="0" indent="0" algn="r">
+              <a:buNone/>
+            </a:pPr>
+            <a:r>
+              <a:rPr lang="fr-FR" sz="1200" dirty="0" b="1">
+                <a:solidFill>
+                  <a:srgbClr val="F59E0B"/>
+                </a:solidFill>
+                <a:latin typeface="Segoe UI"/>
+                <a:cs typeface="Segoe UI"/>
+              </a:rPr>
+              <a:t>2025</a:t>
+            </a:r>
+          </a:p>
+        </p:txBody>
+      </p:sp>
+      <p:sp>
+        <p:nvSpPr>
+          <p:cNvPr id="23" name="Point"/>
+          <p:cNvSpPr/>
+          <p:nvPr/>
+        </p:nvSpPr>
+        <p:spPr>
+          <a:xfrm>
+            <a:off x="4807915" y="5554980"/>
+            <a:ext cx="118872" cy="118872"/>
+          </a:xfrm>
+          <a:prstGeom prst="ellipse">
+            <a:avLst/>
+          </a:prstGeom>
+          <a:solidFill>
+            <a:srgbClr val="F59E0B"/>
+          </a:solidFill>
+          <a:ln w="20320" cap="flat" cmpd="sng" algn="ctr">
+            <a:solidFill>
+              <a:srgbClr val="040E18"/>
+            </a:solidFill>
+            <a:prstDash val="solid"/>
+          </a:ln>
+        </p:spPr>
+        <p:txBody>
+          <a:bodyPr wrap="square" lIns="0" tIns="0" rIns="0" bIns="0" anchor="t">
+            <a:noAutofit/>
+          </a:bodyPr>
+          <a:lstStyle/>
+          <a:p>
+            <a:pPr/>
+            <a:endParaRPr lang="fr-FR"/>
+          </a:p>
+        </p:txBody>
+      </p:sp>
+      <p:sp>
+        <p:nvSpPr>
+          <p:cNvPr id="24" name="Text"/>
+          <p:cNvSpPr/>
+          <p:nvPr/>
+        </p:nvSpPr>
+        <p:spPr>
+          <a:xfrm>
+            <a:off x="5056632" y="5458968"/>
+            <a:ext cx="6357823" cy="310896"/>
+          </a:xfrm>
+          <a:prstGeom prst="rect">
+            <a:avLst/>
+          </a:prstGeom>
+          <a:noFill/>
+          <a:ln>
+            <a:noFill/>
+          </a:ln>
+        </p:spPr>
+        <p:txBody>
+          <a:bodyPr wrap="square" lIns="0" tIns="0" rIns="0" bIns="0" anchor="ctr">
+            <a:noAutofit/>
+          </a:bodyPr>
+          <a:lstStyle/>
           <a:p>
             <a:pPr marL="0" indent="0" algn="l">
-              <a:spcBef>
-                <a:spcPts val="200"/>
-              </a:spcBef>
-              <a:buNone/>
-            </a:pPr>
-            <a:r>
-              <a:rPr lang="fr-FR" sz="1050" dirty="0">
-                <a:solidFill>
-                  <a:srgbClr val="9FB6CE"/>
-                </a:solidFill>
-                <a:latin typeface="Segoe UI"/>
-                <a:cs typeface="Segoe UI"/>
-              </a:rPr>
-              <a:t>École Supérieure de Technologie de Guelmim — Université Ibn Zohr</a:t>
+              <a:buNone/>
+            </a:pPr>
+            <a:r>
+              <a:rPr lang="fr-FR" sz="1200" dirty="0" b="1">
+                <a:solidFill>
+                  <a:srgbClr val="FFFFFF"/>
+                </a:solidFill>
+                <a:latin typeface="Segoe UI"/>
+                <a:cs typeface="Segoe UI"/>
+              </a:rPr>
+              <a:t>Licence Ingénierie de la Production Industrielle et Gestion de Projet</a:t>
+            </a:r>
+          </a:p>
+        </p:txBody>
+      </p:sp>
+      <p:sp>
+        <p:nvSpPr>
+          <p:cNvPr id="25" name="Text"/>
+          <p:cNvSpPr/>
+          <p:nvPr/>
+        </p:nvSpPr>
+        <p:spPr>
+          <a:xfrm>
+            <a:off x="4069080" y="5815584"/>
+            <a:ext cx="658368" cy="310896"/>
+          </a:xfrm>
+          <a:prstGeom prst="rect">
+            <a:avLst/>
+          </a:prstGeom>
+          <a:noFill/>
+          <a:ln>
+            <a:noFill/>
+          </a:ln>
+        </p:spPr>
+        <p:txBody>
+          <a:bodyPr wrap="square" lIns="0" tIns="0" rIns="0" bIns="0" anchor="ctr">
+            <a:noAutofit/>
+          </a:bodyPr>
+          <a:lstStyle/>
+          <a:p>
+            <a:pPr marL="0" indent="0" algn="r">
+              <a:buNone/>
+            </a:pPr>
+            <a:r>
+              <a:rPr lang="fr-FR" sz="1200" dirty="0" b="1">
+                <a:solidFill>
+                  <a:srgbClr val="A78BFA"/>
+                </a:solidFill>
+                <a:latin typeface="Segoe UI"/>
+                <a:cs typeface="Segoe UI"/>
+              </a:rPr>
+              <a:t>2026</a:t>
+            </a:r>
+          </a:p>
+        </p:txBody>
+      </p:sp>
+      <p:sp>
+        <p:nvSpPr>
+          <p:cNvPr id="26" name="Point"/>
+          <p:cNvSpPr/>
+          <p:nvPr/>
+        </p:nvSpPr>
+        <p:spPr>
+          <a:xfrm>
+            <a:off x="4807915" y="5911596"/>
+            <a:ext cx="118872" cy="118872"/>
+          </a:xfrm>
+          <a:prstGeom prst="ellipse">
+            <a:avLst/>
+          </a:prstGeom>
+          <a:solidFill>
+            <a:srgbClr val="A78BFA"/>
+          </a:solidFill>
+          <a:ln w="20320" cap="flat" cmpd="sng" algn="ctr">
+            <a:solidFill>
+              <a:srgbClr val="040E18"/>
+            </a:solidFill>
+            <a:prstDash val="solid"/>
+          </a:ln>
+        </p:spPr>
+        <p:txBody>
+          <a:bodyPr wrap="square" lIns="0" tIns="0" rIns="0" bIns="0" anchor="t">
+            <a:noAutofit/>
+          </a:bodyPr>
+          <a:lstStyle/>
+          <a:p>
+            <a:pPr/>
+            <a:endParaRPr lang="fr-FR"/>
+          </a:p>
+        </p:txBody>
+      </p:sp>
+      <p:sp>
+        <p:nvSpPr>
+          <p:cNvPr id="27" name="Text"/>
+          <p:cNvSpPr/>
+          <p:nvPr/>
+        </p:nvSpPr>
+        <p:spPr>
+          <a:xfrm>
+            <a:off x="5056632" y="5815584"/>
+            <a:ext cx="6357823" cy="310896"/>
+          </a:xfrm>
+          <a:prstGeom prst="rect">
+            <a:avLst/>
+          </a:prstGeom>
+          <a:noFill/>
+          <a:ln>
+            <a:noFill/>
+          </a:ln>
+        </p:spPr>
+        <p:txBody>
+          <a:bodyPr wrap="square" lIns="0" tIns="0" rIns="0" bIns="0" anchor="ctr">
+            <a:noAutofit/>
+          </a:bodyPr>
+          <a:lstStyle/>
+          <a:p>
+            <a:pPr marL="0" indent="0" algn="l">
+              <a:buNone/>
+            </a:pPr>
+            <a:r>
+              <a:rPr lang="fr-FR" sz="1200" dirty="0" b="1">
+                <a:solidFill>
+                  <a:srgbClr val="FFFFFF"/>
+                </a:solidFill>
+                <a:latin typeface="Segoe UI"/>
+                <a:cs typeface="Segoe UI"/>
+              </a:rPr>
+              <a:t>Master Ingénierie et Management Industriel</a:t>
+            </a:r>
+            <a:r>
+              <a:rPr lang="fr-FR" sz="1050" dirty="0" i="1">
+                <a:solidFill>
+                  <a:srgbClr val="A78BFA"/>
+                </a:solidFill>
+                <a:latin typeface="Segoe UI"/>
+                <a:cs typeface="Segoe UI"/>
+              </a:rPr>
+              <a:t>   en cours de validation</a:t>
             </a:r>
           </a:p>
         </p:txBody>
@@ -23356,7 +23567,7 @@
                 <a:latin typeface="Segoe UI"/>
                 <a:cs typeface="Segoe UI"/>
               </a:rPr>
-              <a:t>Un parcours scientifique et technique</a:t>
+              <a:t>Cinq étapes, une même trajectoire</a:t>
             </a:r>
           </a:p>
         </p:txBody>
@@ -23369,8 +23580,8 @@
         </p:nvSpPr>
         <p:spPr>
           <a:xfrm>
-            <a:off x="868680" y="3035808"/>
-            <a:ext cx="10454335" cy="20117"/>
+            <a:off x="2075688" y="2304288"/>
+            <a:ext cx="20117" cy="3246120"/>
           </a:xfrm>
           <a:prstGeom prst="rect">
             <a:avLst/>
@@ -23401,28 +23612,28 @@
         </p:nvSpPr>
         <p:spPr>
           <a:xfrm>
-            <a:off x="777240" y="2377440"/>
-            <a:ext cx="3362858" cy="310896"/>
-          </a:xfrm>
-          <a:prstGeom prst="rect">
-            <a:avLst/>
-          </a:prstGeom>
-          <a:noFill/>
-          <a:ln>
-            <a:noFill/>
-          </a:ln>
-        </p:spPr>
-        <p:txBody>
-          <a:bodyPr wrap="square" lIns="0" tIns="0" rIns="0" bIns="0" anchor="t">
-            <a:noAutofit/>
-          </a:bodyPr>
-          <a:lstStyle/>
-          <a:p>
-            <a:pPr marL="0" indent="0" algn="ctr">
-              <a:buNone/>
-            </a:pPr>
-            <a:r>
-              <a:rPr lang="fr-FR" sz="1450" dirty="0" b="1">
+            <a:off x="777240" y="2139696"/>
+            <a:ext cx="1097280" cy="548640"/>
+          </a:xfrm>
+          <a:prstGeom prst="rect">
+            <a:avLst/>
+          </a:prstGeom>
+          <a:noFill/>
+          <a:ln>
+            <a:noFill/>
+          </a:ln>
+        </p:spPr>
+        <p:txBody>
+          <a:bodyPr wrap="square" lIns="0" tIns="0" rIns="0" bIns="0" anchor="ctr">
+            <a:noAutofit/>
+          </a:bodyPr>
+          <a:lstStyle/>
+          <a:p>
+            <a:pPr marL="0" indent="0" algn="r">
+              <a:buNone/>
+            </a:pPr>
+            <a:r>
+              <a:rPr lang="fr-FR" sz="1400" dirty="0" b="1">
                 <a:solidFill>
                   <a:srgbClr val="5B9DF9"/>
                 </a:solidFill>
@@ -23442,7 +23653,7 @@
         </p:nvSpPr>
         <p:spPr>
           <a:xfrm>
-            <a:off x="2380945" y="2962656"/>
+            <a:off x="2007108" y="2336292"/>
             <a:ext cx="155448" cy="155448"/>
           </a:xfrm>
           <a:prstGeom prst="ellipse">
@@ -23471,43 +23682,32 @@
       </p:sp>
       <p:sp>
         <p:nvSpPr>
-          <p:cNvPr id="10" name="Carte"/>
-          <p:cNvSpPr/>
-          <p:nvPr/>
-        </p:nvSpPr>
-        <p:spPr>
-          <a:xfrm>
-            <a:off x="777240" y="3401568"/>
-            <a:ext cx="3362858" cy="1691640"/>
-          </a:xfrm>
-          <a:prstGeom prst="roundRect">
-            <a:avLst>
-              <a:gd name="adj" fmla="val 6000"/>
-            </a:avLst>
-          </a:prstGeom>
-          <a:solidFill>
-            <a:srgbClr val="0F2842">
-              <a:alpha val="48000"/>
-            </a:srgbClr>
-          </a:solidFill>
-          <a:ln w="15240" cap="flat" cmpd="sng" algn="ctr">
-            <a:solidFill>
-              <a:srgbClr val="5B9DF9">
-                <a:alpha val="50000"/>
-              </a:srgbClr>
-            </a:solidFill>
-            <a:prstDash val="solid"/>
-          </a:ln>
-        </p:spPr>
-        <p:txBody>
-          <a:bodyPr wrap="square" lIns="219456" tIns="146304" rIns="219456" bIns="146304" anchor="ctr">
-            <a:noAutofit/>
-          </a:bodyPr>
-          <a:lstStyle/>
-          <a:p>
-            <a:pPr marL="0" indent="0" algn="ctr">
+          <p:cNvPr id="10" name="Text"/>
+          <p:cNvSpPr/>
+          <p:nvPr/>
+        </p:nvSpPr>
+        <p:spPr>
+          <a:xfrm>
+            <a:off x="2386584" y="2139696"/>
+            <a:ext cx="9027871" cy="548640"/>
+          </a:xfrm>
+          <a:prstGeom prst="rect">
+            <a:avLst/>
+          </a:prstGeom>
+          <a:noFill/>
+          <a:ln>
+            <a:noFill/>
+          </a:ln>
+        </p:spPr>
+        <p:txBody>
+          <a:bodyPr wrap="square" lIns="0" tIns="0" rIns="0" bIns="0" anchor="ctr">
+            <a:noAutofit/>
+          </a:bodyPr>
+          <a:lstStyle/>
+          <a:p>
+            <a:pPr marL="0" indent="0" algn="l">
               <a:lnSpc>
-                <a:spcPct val="120000"/>
+                <a:spcPct val="114999"/>
               </a:lnSpc>
               <a:buNone/>
             </a:pPr>
@@ -23523,12 +23723,9 @@
             </a:r>
           </a:p>
           <a:p>
-            <a:pPr marL="0" indent="0" algn="ctr">
-              <a:lnSpc>
-                <a:spcPct val="130000"/>
-              </a:lnSpc>
+            <a:pPr marL="0" indent="0" algn="l">
               <a:spcBef>
-                <a:spcPts val="700"/>
+                <a:spcPts val="300"/>
               </a:spcBef>
               <a:buNone/>
             </a:pPr>
@@ -23553,28 +23750,28 @@
         </p:nvSpPr>
         <p:spPr>
           <a:xfrm>
-            <a:off x="4414418" y="2377440"/>
-            <a:ext cx="3362858" cy="310896"/>
-          </a:xfrm>
-          <a:prstGeom prst="rect">
-            <a:avLst/>
-          </a:prstGeom>
-          <a:noFill/>
-          <a:ln>
-            <a:noFill/>
-          </a:ln>
-        </p:spPr>
-        <p:txBody>
-          <a:bodyPr wrap="square" lIns="0" tIns="0" rIns="0" bIns="0" anchor="t">
-            <a:noAutofit/>
-          </a:bodyPr>
-          <a:lstStyle/>
-          <a:p>
-            <a:pPr marL="0" indent="0" algn="ctr">
-              <a:buNone/>
-            </a:pPr>
-            <a:r>
-              <a:rPr lang="fr-FR" sz="1450" dirty="0" b="1">
+            <a:off x="777240" y="2944368"/>
+            <a:ext cx="1097280" cy="548640"/>
+          </a:xfrm>
+          <a:prstGeom prst="rect">
+            <a:avLst/>
+          </a:prstGeom>
+          <a:noFill/>
+          <a:ln>
+            <a:noFill/>
+          </a:ln>
+        </p:spPr>
+        <p:txBody>
+          <a:bodyPr wrap="square" lIns="0" tIns="0" rIns="0" bIns="0" anchor="ctr">
+            <a:noAutofit/>
+          </a:bodyPr>
+          <a:lstStyle/>
+          <a:p>
+            <a:pPr marL="0" indent="0" algn="r">
+              <a:buNone/>
+            </a:pPr>
+            <a:r>
+              <a:rPr lang="fr-FR" sz="1400" dirty="0" b="1">
                 <a:solidFill>
                   <a:srgbClr val="22D3EE"/>
                 </a:solidFill>
@@ -23594,7 +23791,7 @@
         </p:nvSpPr>
         <p:spPr>
           <a:xfrm>
-            <a:off x="6018124" y="2962656"/>
+            <a:off x="2007108" y="3140964"/>
             <a:ext cx="155448" cy="155448"/>
           </a:xfrm>
           <a:prstGeom prst="ellipse">
@@ -23623,43 +23820,32 @@
       </p:sp>
       <p:sp>
         <p:nvSpPr>
-          <p:cNvPr id="13" name="Carte"/>
-          <p:cNvSpPr/>
-          <p:nvPr/>
-        </p:nvSpPr>
-        <p:spPr>
-          <a:xfrm>
-            <a:off x="4414418" y="3401568"/>
-            <a:ext cx="3362858" cy="1691640"/>
-          </a:xfrm>
-          <a:prstGeom prst="roundRect">
-            <a:avLst>
-              <a:gd name="adj" fmla="val 6000"/>
-            </a:avLst>
-          </a:prstGeom>
-          <a:solidFill>
-            <a:srgbClr val="0F2842">
-              <a:alpha val="48000"/>
-            </a:srgbClr>
-          </a:solidFill>
-          <a:ln w="15240" cap="flat" cmpd="sng" algn="ctr">
-            <a:solidFill>
-              <a:srgbClr val="22D3EE">
-                <a:alpha val="50000"/>
-              </a:srgbClr>
-            </a:solidFill>
-            <a:prstDash val="solid"/>
-          </a:ln>
-        </p:spPr>
-        <p:txBody>
-          <a:bodyPr wrap="square" lIns="219456" tIns="146304" rIns="219456" bIns="146304" anchor="ctr">
-            <a:noAutofit/>
-          </a:bodyPr>
-          <a:lstStyle/>
-          <a:p>
-            <a:pPr marL="0" indent="0" algn="ctr">
+          <p:cNvPr id="13" name="Text"/>
+          <p:cNvSpPr/>
+          <p:nvPr/>
+        </p:nvSpPr>
+        <p:spPr>
+          <a:xfrm>
+            <a:off x="2386584" y="2944368"/>
+            <a:ext cx="9027871" cy="548640"/>
+          </a:xfrm>
+          <a:prstGeom prst="rect">
+            <a:avLst/>
+          </a:prstGeom>
+          <a:noFill/>
+          <a:ln>
+            <a:noFill/>
+          </a:ln>
+        </p:spPr>
+        <p:txBody>
+          <a:bodyPr wrap="square" lIns="0" tIns="0" rIns="0" bIns="0" anchor="ctr">
+            <a:noAutofit/>
+          </a:bodyPr>
+          <a:lstStyle/>
+          <a:p>
+            <a:pPr marL="0" indent="0" algn="l">
               <a:lnSpc>
-                <a:spcPct val="120000"/>
+                <a:spcPct val="114999"/>
               </a:lnSpc>
               <a:buNone/>
             </a:pPr>
@@ -23675,12 +23861,9 @@
             </a:r>
           </a:p>
           <a:p>
-            <a:pPr marL="0" indent="0" algn="ctr">
-              <a:lnSpc>
-                <a:spcPct val="130000"/>
-              </a:lnSpc>
+            <a:pPr marL="0" indent="0" algn="l">
               <a:spcBef>
-                <a:spcPts val="700"/>
+                <a:spcPts val="300"/>
               </a:spcBef>
               <a:buNone/>
             </a:pPr>
@@ -23705,28 +23888,28 @@
         </p:nvSpPr>
         <p:spPr>
           <a:xfrm>
-            <a:off x="8051597" y="2377440"/>
-            <a:ext cx="3362858" cy="310896"/>
-          </a:xfrm>
-          <a:prstGeom prst="rect">
-            <a:avLst/>
-          </a:prstGeom>
-          <a:noFill/>
-          <a:ln>
-            <a:noFill/>
-          </a:ln>
-        </p:spPr>
-        <p:txBody>
-          <a:bodyPr wrap="square" lIns="0" tIns="0" rIns="0" bIns="0" anchor="t">
-            <a:noAutofit/>
-          </a:bodyPr>
-          <a:lstStyle/>
-          <a:p>
-            <a:pPr marL="0" indent="0" algn="ctr">
-              <a:buNone/>
-            </a:pPr>
-            <a:r>
-              <a:rPr lang="fr-FR" sz="1450" dirty="0" b="1">
+            <a:off x="777240" y="3749040"/>
+            <a:ext cx="1097280" cy="548640"/>
+          </a:xfrm>
+          <a:prstGeom prst="rect">
+            <a:avLst/>
+          </a:prstGeom>
+          <a:noFill/>
+          <a:ln>
+            <a:noFill/>
+          </a:ln>
+        </p:spPr>
+        <p:txBody>
+          <a:bodyPr wrap="square" lIns="0" tIns="0" rIns="0" bIns="0" anchor="ctr">
+            <a:noAutofit/>
+          </a:bodyPr>
+          <a:lstStyle/>
+          <a:p>
+            <a:pPr marL="0" indent="0" algn="r">
+              <a:buNone/>
+            </a:pPr>
+            <a:r>
+              <a:rPr lang="fr-FR" sz="1400" dirty="0" b="1">
                 <a:solidFill>
                   <a:srgbClr val="34D399"/>
                 </a:solidFill>
@@ -23746,7 +23929,7 @@
         </p:nvSpPr>
         <p:spPr>
           <a:xfrm>
-            <a:off x="9655302" y="2962656"/>
+            <a:off x="2007108" y="3945636"/>
             <a:ext cx="155448" cy="155448"/>
           </a:xfrm>
           <a:prstGeom prst="ellipse">
@@ -23775,43 +23958,170 @@
       </p:sp>
       <p:sp>
         <p:nvSpPr>
-          <p:cNvPr id="16" name="Carte"/>
-          <p:cNvSpPr/>
-          <p:nvPr/>
-        </p:nvSpPr>
-        <p:spPr>
-          <a:xfrm>
-            <a:off x="8051597" y="3401568"/>
-            <a:ext cx="3362858" cy="1691640"/>
-          </a:xfrm>
-          <a:prstGeom prst="roundRect">
-            <a:avLst>
-              <a:gd name="adj" fmla="val 6000"/>
-            </a:avLst>
+          <p:cNvPr id="16" name="Text"/>
+          <p:cNvSpPr/>
+          <p:nvPr/>
+        </p:nvSpPr>
+        <p:spPr>
+          <a:xfrm>
+            <a:off x="2386584" y="3749040"/>
+            <a:ext cx="9027871" cy="548640"/>
+          </a:xfrm>
+          <a:prstGeom prst="rect">
+            <a:avLst/>
+          </a:prstGeom>
+          <a:noFill/>
+          <a:ln>
+            <a:noFill/>
+          </a:ln>
+        </p:spPr>
+        <p:txBody>
+          <a:bodyPr wrap="square" lIns="0" tIns="0" rIns="0" bIns="0" anchor="ctr">
+            <a:noAutofit/>
+          </a:bodyPr>
+          <a:lstStyle/>
+          <a:p>
+            <a:pPr marL="0" indent="0" algn="l">
+              <a:lnSpc>
+                <a:spcPct val="114999"/>
+              </a:lnSpc>
+              <a:buNone/>
+            </a:pPr>
+            <a:r>
+              <a:rPr lang="fr-FR" sz="1500" dirty="0" b="1">
+                <a:solidFill>
+                  <a:srgbClr val="FFFFFF"/>
+                </a:solidFill>
+                <a:latin typeface="Segoe UI"/>
+                <a:cs typeface="Segoe UI"/>
+              </a:rPr>
+              <a:t>DUT — Génie Électrique</a:t>
+            </a:r>
+          </a:p>
+          <a:p>
+            <a:pPr marL="0" indent="0" algn="l">
+              <a:spcBef>
+                <a:spcPts val="300"/>
+              </a:spcBef>
+              <a:buNone/>
+            </a:pPr>
+            <a:r>
+              <a:rPr lang="fr-FR" sz="1150" dirty="0">
+                <a:solidFill>
+                  <a:srgbClr val="9FB6CE"/>
+                </a:solidFill>
+                <a:latin typeface="Segoe UI"/>
+                <a:cs typeface="Segoe UI"/>
+              </a:rPr>
+              <a:t>École Supérieure de Technologie de Guelmim — Université Ibn Zohr</a:t>
+            </a:r>
+          </a:p>
+        </p:txBody>
+      </p:sp>
+      <p:sp>
+        <p:nvSpPr>
+          <p:cNvPr id="17" name="Text"/>
+          <p:cNvSpPr/>
+          <p:nvPr/>
+        </p:nvSpPr>
+        <p:spPr>
+          <a:xfrm>
+            <a:off x="777240" y="4553712"/>
+            <a:ext cx="1097280" cy="548640"/>
+          </a:xfrm>
+          <a:prstGeom prst="rect">
+            <a:avLst/>
+          </a:prstGeom>
+          <a:noFill/>
+          <a:ln>
+            <a:noFill/>
+          </a:ln>
+        </p:spPr>
+        <p:txBody>
+          <a:bodyPr wrap="square" lIns="0" tIns="0" rIns="0" bIns="0" anchor="ctr">
+            <a:noAutofit/>
+          </a:bodyPr>
+          <a:lstStyle/>
+          <a:p>
+            <a:pPr marL="0" indent="0" algn="r">
+              <a:buNone/>
+            </a:pPr>
+            <a:r>
+              <a:rPr lang="fr-FR" sz="1400" dirty="0" b="1">
+                <a:solidFill>
+                  <a:srgbClr val="F59E0B"/>
+                </a:solidFill>
+                <a:latin typeface="Segoe UI"/>
+                <a:cs typeface="Segoe UI"/>
+              </a:rPr>
+              <a:t>2025</a:t>
+            </a:r>
+          </a:p>
+        </p:txBody>
+      </p:sp>
+      <p:sp>
+        <p:nvSpPr>
+          <p:cNvPr id="18" name="Point"/>
+          <p:cNvSpPr/>
+          <p:nvPr/>
+        </p:nvSpPr>
+        <p:spPr>
+          <a:xfrm>
+            <a:off x="2007108" y="4750308"/>
+            <a:ext cx="155448" cy="155448"/>
+          </a:xfrm>
+          <a:prstGeom prst="ellipse">
+            <a:avLst/>
           </a:prstGeom>
           <a:solidFill>
-            <a:srgbClr val="0F2842">
-              <a:alpha val="48000"/>
-            </a:srgbClr>
+            <a:srgbClr val="F59E0B"/>
           </a:solidFill>
-          <a:ln w="15240" cap="flat" cmpd="sng" algn="ctr">
+          <a:ln w="25400" cap="flat" cmpd="sng" algn="ctr">
             <a:solidFill>
-              <a:srgbClr val="34D399">
-                <a:alpha val="50000"/>
-              </a:srgbClr>
+              <a:srgbClr val="040E18"/>
             </a:solidFill>
             <a:prstDash val="solid"/>
           </a:ln>
         </p:spPr>
         <p:txBody>
-          <a:bodyPr wrap="square" lIns="219456" tIns="146304" rIns="219456" bIns="146304" anchor="ctr">
-            <a:noAutofit/>
-          </a:bodyPr>
-          <a:lstStyle/>
-          <a:p>
-            <a:pPr marL="0" indent="0" algn="ctr">
+          <a:bodyPr wrap="square" lIns="0" tIns="0" rIns="0" bIns="0" anchor="t">
+            <a:noAutofit/>
+          </a:bodyPr>
+          <a:lstStyle/>
+          <a:p>
+            <a:pPr/>
+            <a:endParaRPr lang="fr-FR"/>
+          </a:p>
+        </p:txBody>
+      </p:sp>
+      <p:sp>
+        <p:nvSpPr>
+          <p:cNvPr id="19" name="Text"/>
+          <p:cNvSpPr/>
+          <p:nvPr/>
+        </p:nvSpPr>
+        <p:spPr>
+          <a:xfrm>
+            <a:off x="2386584" y="4553712"/>
+            <a:ext cx="9027871" cy="548640"/>
+          </a:xfrm>
+          <a:prstGeom prst="rect">
+            <a:avLst/>
+          </a:prstGeom>
+          <a:noFill/>
+          <a:ln>
+            <a:noFill/>
+          </a:ln>
+        </p:spPr>
+        <p:txBody>
+          <a:bodyPr wrap="square" lIns="0" tIns="0" rIns="0" bIns="0" anchor="ctr">
+            <a:noAutofit/>
+          </a:bodyPr>
+          <a:lstStyle/>
+          <a:p>
+            <a:pPr marL="0" indent="0" algn="l">
               <a:lnSpc>
-                <a:spcPct val="120000"/>
+                <a:spcPct val="114999"/>
               </a:lnSpc>
               <a:buNone/>
             </a:pPr>
@@ -23823,16 +24133,13 @@
                 <a:latin typeface="Segoe UI"/>
                 <a:cs typeface="Segoe UI"/>
               </a:rPr>
-              <a:t>DUT — Génie Électrique</a:t>
-            </a:r>
-          </a:p>
-          <a:p>
-            <a:pPr marL="0" indent="0" algn="ctr">
-              <a:lnSpc>
-                <a:spcPct val="130000"/>
-              </a:lnSpc>
+              <a:t>Licence — Ingénierie de la Production Industrielle et Gestion de Projet</a:t>
+            </a:r>
+          </a:p>
+          <a:p>
+            <a:pPr marL="0" indent="0" algn="l">
               <a:spcBef>
-                <a:spcPts val="700"/>
+                <a:spcPts val="300"/>
               </a:spcBef>
               <a:buNone/>
             </a:pPr>
@@ -23844,7 +24151,152 @@
                 <a:latin typeface="Segoe UI"/>
                 <a:cs typeface="Segoe UI"/>
               </a:rPr>
-              <a:t>École Supérieure de Technologie de Guelmim, Université Ibn Zohr</a:t>
+              <a:t>Établissement à compléter</a:t>
+            </a:r>
+          </a:p>
+        </p:txBody>
+      </p:sp>
+      <p:sp>
+        <p:nvSpPr>
+          <p:cNvPr id="20" name="Text"/>
+          <p:cNvSpPr/>
+          <p:nvPr/>
+        </p:nvSpPr>
+        <p:spPr>
+          <a:xfrm>
+            <a:off x="777240" y="5358384"/>
+            <a:ext cx="1097280" cy="548640"/>
+          </a:xfrm>
+          <a:prstGeom prst="rect">
+            <a:avLst/>
+          </a:prstGeom>
+          <a:noFill/>
+          <a:ln>
+            <a:noFill/>
+          </a:ln>
+        </p:spPr>
+        <p:txBody>
+          <a:bodyPr wrap="square" lIns="0" tIns="0" rIns="0" bIns="0" anchor="ctr">
+            <a:noAutofit/>
+          </a:bodyPr>
+          <a:lstStyle/>
+          <a:p>
+            <a:pPr marL="0" indent="0" algn="r">
+              <a:buNone/>
+            </a:pPr>
+            <a:r>
+              <a:rPr lang="fr-FR" sz="1400" dirty="0" b="1">
+                <a:solidFill>
+                  <a:srgbClr val="A78BFA"/>
+                </a:solidFill>
+                <a:latin typeface="Segoe UI"/>
+                <a:cs typeface="Segoe UI"/>
+              </a:rPr>
+              <a:t>2026</a:t>
+            </a:r>
+          </a:p>
+        </p:txBody>
+      </p:sp>
+      <p:sp>
+        <p:nvSpPr>
+          <p:cNvPr id="21" name="Point"/>
+          <p:cNvSpPr/>
+          <p:nvPr/>
+        </p:nvSpPr>
+        <p:spPr>
+          <a:xfrm>
+            <a:off x="2007108" y="5554980"/>
+            <a:ext cx="155448" cy="155448"/>
+          </a:xfrm>
+          <a:prstGeom prst="ellipse">
+            <a:avLst/>
+          </a:prstGeom>
+          <a:solidFill>
+            <a:srgbClr val="A78BFA"/>
+          </a:solidFill>
+          <a:ln w="25400" cap="flat" cmpd="sng" algn="ctr">
+            <a:solidFill>
+              <a:srgbClr val="040E18"/>
+            </a:solidFill>
+            <a:prstDash val="solid"/>
+          </a:ln>
+        </p:spPr>
+        <p:txBody>
+          <a:bodyPr wrap="square" lIns="0" tIns="0" rIns="0" bIns="0" anchor="t">
+            <a:noAutofit/>
+          </a:bodyPr>
+          <a:lstStyle/>
+          <a:p>
+            <a:pPr/>
+            <a:endParaRPr lang="fr-FR"/>
+          </a:p>
+        </p:txBody>
+      </p:sp>
+      <p:sp>
+        <p:nvSpPr>
+          <p:cNvPr id="22" name="Text"/>
+          <p:cNvSpPr/>
+          <p:nvPr/>
+        </p:nvSpPr>
+        <p:spPr>
+          <a:xfrm>
+            <a:off x="2386584" y="5358384"/>
+            <a:ext cx="9027871" cy="548640"/>
+          </a:xfrm>
+          <a:prstGeom prst="rect">
+            <a:avLst/>
+          </a:prstGeom>
+          <a:noFill/>
+          <a:ln>
+            <a:noFill/>
+          </a:ln>
+        </p:spPr>
+        <p:txBody>
+          <a:bodyPr wrap="square" lIns="0" tIns="0" rIns="0" bIns="0" anchor="ctr">
+            <a:noAutofit/>
+          </a:bodyPr>
+          <a:lstStyle/>
+          <a:p>
+            <a:pPr marL="0" indent="0" algn="l">
+              <a:buNone/>
+            </a:pPr>
+            <a:r>
+              <a:rPr lang="fr-FR" sz="1500" dirty="0" b="1">
+                <a:solidFill>
+                  <a:srgbClr val="FFFFFF"/>
+                </a:solidFill>
+                <a:latin typeface="Segoe UI"/>
+                <a:cs typeface="Segoe UI"/>
+              </a:rPr>
+              <a:t>Master — Ingénierie et Management Industriel</a:t>
+            </a:r>
+            <a:r>
+              <a:rPr lang="fr-FR" sz="1100" dirty="0" b="1" i="1">
+                <a:solidFill>
+                  <a:srgbClr val="A78BFA"/>
+                </a:solidFill>
+                <a:latin typeface="Segoe UI"/>
+                <a:cs typeface="Segoe UI"/>
+              </a:rPr>
+              <a:t>   En cours de validation</a:t>
+            </a:r>
+          </a:p>
+          <a:p>
+            <a:pPr marL="0" indent="0" algn="l">
+              <a:spcBef>
+                <a:spcPts val="300"/>
+              </a:spcBef>
+              <a:buNone/>
+            </a:pPr>
+            <a:r>
+              <a:rPr lang="fr-FR" sz="1150" dirty="0">
+                <a:solidFill>
+                  <a:srgbClr val="9FB6CE"/>
+                </a:solidFill>
+                <a:latin typeface="Segoe UI"/>
+                <a:cs typeface="Segoe UI"/>
+              </a:rPr>
+              <a:t>Établissement à compléter</a:t>
             </a:r>
           </a:p>
         </p:txBody>

</xml_diff>